<commit_message>
Sync 09/04/2026 : +21 skills (54 total) + hooks + memory + settings
Nouveaux skills : adaptive-thinking-router, antigravity, context-compressor,
diagram-toolkit, gemini-cli, gsheet-builder, haiku-delegator, idea-to-diagram,
image-generator, layout-qa, n8n-code-javascript, n8n-code-python,
n8n-expression-syntax, n8n-management, n8n-mcp-tools-expert,
n8n-node-configuration, n8n-validation-expert, n8n-workflow-patterns,
prompt-cache-manager, skill-tree-manager, token-economizer

Aussi : hooks/ (2 fichiers), 10 nouveaux memory, settings.json + settings.local.json,
CLAUDE.md, statusline.py, README refresh, .gitignore renforcé

Co-Authored-By: Claude Opus 4.6 <noreply@anthropic.com>
</commit_message>
<xml_diff>
--- a/skills/ppt-creator/templates/data_deck.pptx
+++ b/skills/ppt-creator/templates/data_deck.pptx
@@ -3101,14 +3101,57 @@
       <p:grpSpPr/>
       <p:sp>
         <p:nvSpPr>
-          <p:cNvPr id="2" name="TextBox 1"/>
+          <p:cNvPr id="2" name="Rectangle 1"/>
+          <p:cNvSpPr/>
+          <p:nvPr/>
+        </p:nvSpPr>
+        <p:spPr>
+          <a:xfrm>
+            <a:off x="914400" y="3017520"/>
+            <a:ext cx="1828800" cy="54864"/>
+          </a:xfrm>
+          <a:prstGeom prst="rect">
+            <a:avLst/>
+          </a:prstGeom>
+          <a:solidFill>
+            <a:srgbClr val="E63946"/>
+          </a:solidFill>
+          <a:ln>
+            <a:noFill/>
+          </a:ln>
+        </p:spPr>
+        <p:style>
+          <a:lnRef idx="1">
+            <a:schemeClr val="accent1"/>
+          </a:lnRef>
+          <a:fillRef idx="3">
+            <a:schemeClr val="accent1"/>
+          </a:fillRef>
+          <a:effectRef idx="2">
+            <a:schemeClr val="accent1"/>
+          </a:effectRef>
+          <a:fontRef idx="minor">
+            <a:schemeClr val="lt1"/>
+          </a:fontRef>
+        </p:style>
+        <p:txBody>
+          <a:bodyPr rtlCol="0" anchor="ctr"/>
+          <a:lstStyle/>
+          <a:p>
+            <a:pPr algn="ctr"/>
+          </a:p>
+        </p:txBody>
+      </p:sp>
+      <p:sp>
+        <p:nvSpPr>
+          <p:cNvPr id="3" name="TextBox 2"/>
           <p:cNvSpPr txBox="1"/>
           <p:nvPr/>
         </p:nvSpPr>
         <p:spPr>
           <a:xfrm>
-            <a:off x="457200" y="365760"/>
-            <a:ext cx="11247120" cy="822960"/>
+            <a:off x="914400" y="1828800"/>
+            <a:ext cx="8229600" cy="1371600"/>
           </a:xfrm>
           <a:prstGeom prst="rect">
             <a:avLst/>
@@ -3116,18 +3159,65 @@
           <a:noFill/>
         </p:spPr>
         <p:txBody>
-          <a:bodyPr wrap="none">
-            <a:spAutoFit/>
-          </a:bodyPr>
-          <a:lstStyle/>
-          <a:p>
-            <a:r>
-              <a:rPr sz="2400" b="1">
+          <a:bodyPr wrap="square"/>
+          <a:lstStyle/>
+          <a:p>
+            <a:pPr algn="l">
+              <a:spcBef>
+                <a:spcPts val="0"/>
+              </a:spcBef>
+              <a:spcAft>
+                <a:spcPts val="0"/>
+              </a:spcAft>
+            </a:pPr>
+            <a:r>
+              <a:rPr sz="3600" b="1">
                 <a:solidFill>
-                  <a:srgbClr val="0B3D91"/>
+                  <a:srgbClr val="111111"/>
                 </a:solidFill>
+                <a:latin typeface="Calibri"/>
               </a:rPr>
-              <a:t>[1/12] Title</a:t>
+              <a:t>[data_deck]</a:t>
+            </a:r>
+          </a:p>
+        </p:txBody>
+      </p:sp>
+      <p:sp>
+        <p:nvSpPr>
+          <p:cNvPr id="4" name="TextBox 3"/>
+          <p:cNvSpPr txBox="1"/>
+          <p:nvPr/>
+        </p:nvSpPr>
+        <p:spPr>
+          <a:xfrm>
+            <a:off x="914400" y="3474720"/>
+            <a:ext cx="8229600" cy="731520"/>
+          </a:xfrm>
+          <a:prstGeom prst="rect">
+            <a:avLst/>
+          </a:prstGeom>
+          <a:noFill/>
+        </p:spPr>
+        <p:txBody>
+          <a:bodyPr wrap="square"/>
+          <a:lstStyle/>
+          <a:p>
+            <a:pPr algn="l">
+              <a:spcBef>
+                <a:spcPts val="0"/>
+              </a:spcBef>
+              <a:spcAft>
+                <a:spcPts val="0"/>
+              </a:spcAft>
+            </a:pPr>
+            <a:r>
+              <a:rPr sz="1800" b="0">
+                <a:solidFill>
+                  <a:srgbClr val="9CA3AF"/>
+                </a:solidFill>
+                <a:latin typeface="Calibri"/>
+              </a:rPr>
+              <a:t>Template — 12 slides</a:t>
             </a:r>
           </a:p>
         </p:txBody>
@@ -3152,14 +3242,100 @@
       <p:grpSpPr/>
       <p:sp>
         <p:nvSpPr>
-          <p:cNvPr id="2" name="TextBox 1"/>
+          <p:cNvPr id="2" name="Rectangle 1"/>
+          <p:cNvSpPr/>
+          <p:nvPr/>
+        </p:nvSpPr>
+        <p:spPr>
+          <a:xfrm>
+            <a:off x="0" y="0"/>
+            <a:ext cx="12191695" cy="36576"/>
+          </a:xfrm>
+          <a:prstGeom prst="rect">
+            <a:avLst/>
+          </a:prstGeom>
+          <a:solidFill>
+            <a:srgbClr val="E63946"/>
+          </a:solidFill>
+          <a:ln>
+            <a:noFill/>
+          </a:ln>
+        </p:spPr>
+        <p:style>
+          <a:lnRef idx="1">
+            <a:schemeClr val="accent1"/>
+          </a:lnRef>
+          <a:fillRef idx="3">
+            <a:schemeClr val="accent1"/>
+          </a:fillRef>
+          <a:effectRef idx="2">
+            <a:schemeClr val="accent1"/>
+          </a:effectRef>
+          <a:fontRef idx="minor">
+            <a:schemeClr val="lt1"/>
+          </a:fontRef>
+        </p:style>
+        <p:txBody>
+          <a:bodyPr rtlCol="0" anchor="ctr"/>
+          <a:lstStyle/>
+          <a:p>
+            <a:pPr algn="ctr"/>
+          </a:p>
+        </p:txBody>
+      </p:sp>
+      <p:sp>
+        <p:nvSpPr>
+          <p:cNvPr id="3" name="Rectangle 2"/>
+          <p:cNvSpPr/>
+          <p:nvPr/>
+        </p:nvSpPr>
+        <p:spPr>
+          <a:xfrm>
+            <a:off x="0" y="36576"/>
+            <a:ext cx="12191695" cy="1005840"/>
+          </a:xfrm>
+          <a:prstGeom prst="rect">
+            <a:avLst/>
+          </a:prstGeom>
+          <a:solidFill>
+            <a:srgbClr val="F5F5F5"/>
+          </a:solidFill>
+          <a:ln>
+            <a:noFill/>
+          </a:ln>
+        </p:spPr>
+        <p:style>
+          <a:lnRef idx="1">
+            <a:schemeClr val="accent1"/>
+          </a:lnRef>
+          <a:fillRef idx="3">
+            <a:schemeClr val="accent1"/>
+          </a:fillRef>
+          <a:effectRef idx="2">
+            <a:schemeClr val="accent1"/>
+          </a:effectRef>
+          <a:fontRef idx="minor">
+            <a:schemeClr val="lt1"/>
+          </a:fontRef>
+        </p:style>
+        <p:txBody>
+          <a:bodyPr rtlCol="0" anchor="ctr"/>
+          <a:lstStyle/>
+          <a:p>
+            <a:pPr algn="ctr"/>
+          </a:p>
+        </p:txBody>
+      </p:sp>
+      <p:sp>
+        <p:nvSpPr>
+          <p:cNvPr id="4" name="TextBox 3"/>
           <p:cNvSpPr txBox="1"/>
           <p:nvPr/>
         </p:nvSpPr>
         <p:spPr>
           <a:xfrm>
-            <a:off x="457200" y="365760"/>
-            <a:ext cx="11247120" cy="822960"/>
+            <a:off x="640080" y="164592"/>
+            <a:ext cx="10515600" cy="731520"/>
           </a:xfrm>
           <a:prstGeom prst="rect">
             <a:avLst/>
@@ -3167,18 +3343,191 @@
           <a:noFill/>
         </p:spPr>
         <p:txBody>
-          <a:bodyPr wrap="none">
-            <a:spAutoFit/>
-          </a:bodyPr>
-          <a:lstStyle/>
-          <a:p>
-            <a:r>
-              <a:rPr sz="2400" b="1">
+          <a:bodyPr wrap="square"/>
+          <a:lstStyle/>
+          <a:p>
+            <a:pPr algn="l">
+              <a:spcBef>
+                <a:spcPts val="0"/>
+              </a:spcBef>
+              <a:spcAft>
+                <a:spcPts val="0"/>
+              </a:spcAft>
+            </a:pPr>
+            <a:r>
+              <a:rPr sz="2200" b="1">
                 <a:solidFill>
-                  <a:srgbClr val="0B3D91"/>
+                  <a:srgbClr val="111111"/>
                 </a:solidFill>
+                <a:latin typeface="Calibri"/>
               </a:rPr>
               <a:t>[10/12] Chart 8</a:t>
+            </a:r>
+          </a:p>
+        </p:txBody>
+      </p:sp>
+      <p:sp>
+        <p:nvSpPr>
+          <p:cNvPr id="5" name="Rectangle 4"/>
+          <p:cNvSpPr/>
+          <p:nvPr/>
+        </p:nvSpPr>
+        <p:spPr>
+          <a:xfrm>
+            <a:off x="640080" y="1042415"/>
+            <a:ext cx="10058400" cy="18288"/>
+          </a:xfrm>
+          <a:prstGeom prst="rect">
+            <a:avLst/>
+          </a:prstGeom>
+          <a:solidFill>
+            <a:srgbClr val="9CA3AF"/>
+          </a:solidFill>
+          <a:ln>
+            <a:noFill/>
+          </a:ln>
+        </p:spPr>
+        <p:style>
+          <a:lnRef idx="1">
+            <a:schemeClr val="accent1"/>
+          </a:lnRef>
+          <a:fillRef idx="3">
+            <a:schemeClr val="accent1"/>
+          </a:fillRef>
+          <a:effectRef idx="2">
+            <a:schemeClr val="accent1"/>
+          </a:effectRef>
+          <a:fontRef idx="minor">
+            <a:schemeClr val="lt1"/>
+          </a:fontRef>
+        </p:style>
+        <p:txBody>
+          <a:bodyPr rtlCol="0" anchor="ctr"/>
+          <a:lstStyle/>
+          <a:p>
+            <a:pPr algn="ctr"/>
+          </a:p>
+        </p:txBody>
+      </p:sp>
+      <p:sp>
+        <p:nvSpPr>
+          <p:cNvPr id="6" name="Rectangle 5"/>
+          <p:cNvSpPr/>
+          <p:nvPr/>
+        </p:nvSpPr>
+        <p:spPr>
+          <a:xfrm>
+            <a:off x="640080" y="6446520"/>
+            <a:ext cx="10515600" cy="9144"/>
+          </a:xfrm>
+          <a:prstGeom prst="rect">
+            <a:avLst/>
+          </a:prstGeom>
+          <a:solidFill>
+            <a:srgbClr val="9CA3AF"/>
+          </a:solidFill>
+          <a:ln>
+            <a:noFill/>
+          </a:ln>
+        </p:spPr>
+        <p:style>
+          <a:lnRef idx="1">
+            <a:schemeClr val="accent1"/>
+          </a:lnRef>
+          <a:fillRef idx="3">
+            <a:schemeClr val="accent1"/>
+          </a:fillRef>
+          <a:effectRef idx="2">
+            <a:schemeClr val="accent1"/>
+          </a:effectRef>
+          <a:fontRef idx="minor">
+            <a:schemeClr val="lt1"/>
+          </a:fontRef>
+        </p:style>
+        <p:txBody>
+          <a:bodyPr rtlCol="0" anchor="ctr"/>
+          <a:lstStyle/>
+          <a:p>
+            <a:pPr algn="ctr"/>
+          </a:p>
+        </p:txBody>
+      </p:sp>
+      <p:sp>
+        <p:nvSpPr>
+          <p:cNvPr id="7" name="TextBox 6"/>
+          <p:cNvSpPr txBox="1"/>
+          <p:nvPr/>
+        </p:nvSpPr>
+        <p:spPr>
+          <a:xfrm>
+            <a:off x="11155680" y="6492240"/>
+            <a:ext cx="731520" cy="274320"/>
+          </a:xfrm>
+          <a:prstGeom prst="rect">
+            <a:avLst/>
+          </a:prstGeom>
+          <a:noFill/>
+        </p:spPr>
+        <p:txBody>
+          <a:bodyPr wrap="square"/>
+          <a:lstStyle/>
+          <a:p>
+            <a:pPr algn="r">
+              <a:spcBef>
+                <a:spcPts val="0"/>
+              </a:spcBef>
+              <a:spcAft>
+                <a:spcPts val="0"/>
+              </a:spcAft>
+            </a:pPr>
+            <a:r>
+              <a:rPr sz="900" b="0">
+                <a:solidFill>
+                  <a:srgbClr val="9CA3AF"/>
+                </a:solidFill>
+                <a:latin typeface="Calibri"/>
+              </a:rPr>
+              <a:t>10/12</a:t>
+            </a:r>
+          </a:p>
+        </p:txBody>
+      </p:sp>
+      <p:sp>
+        <p:nvSpPr>
+          <p:cNvPr id="8" name="TextBox 7"/>
+          <p:cNvSpPr txBox="1"/>
+          <p:nvPr/>
+        </p:nvSpPr>
+        <p:spPr>
+          <a:xfrm>
+            <a:off x="640080" y="6492240"/>
+            <a:ext cx="2743200" cy="274320"/>
+          </a:xfrm>
+          <a:prstGeom prst="rect">
+            <a:avLst/>
+          </a:prstGeom>
+          <a:noFill/>
+        </p:spPr>
+        <p:txBody>
+          <a:bodyPr wrap="square"/>
+          <a:lstStyle/>
+          <a:p>
+            <a:pPr algn="l">
+              <a:spcBef>
+                <a:spcPts val="0"/>
+              </a:spcBef>
+              <a:spcAft>
+                <a:spcPts val="0"/>
+              </a:spcAft>
+            </a:pPr>
+            <a:r>
+              <a:rPr sz="800" b="0">
+                <a:solidFill>
+                  <a:srgbClr val="9CA3AF"/>
+                </a:solidFill>
+                <a:latin typeface="Calibri"/>
+              </a:rPr>
+              <a:t>CONFIDENTIEL</a:t>
             </a:r>
           </a:p>
         </p:txBody>
@@ -3203,14 +3552,100 @@
       <p:grpSpPr/>
       <p:sp>
         <p:nvSpPr>
-          <p:cNvPr id="2" name="TextBox 1"/>
+          <p:cNvPr id="2" name="Rectangle 1"/>
+          <p:cNvSpPr/>
+          <p:nvPr/>
+        </p:nvSpPr>
+        <p:spPr>
+          <a:xfrm>
+            <a:off x="0" y="0"/>
+            <a:ext cx="12191695" cy="36576"/>
+          </a:xfrm>
+          <a:prstGeom prst="rect">
+            <a:avLst/>
+          </a:prstGeom>
+          <a:solidFill>
+            <a:srgbClr val="E63946"/>
+          </a:solidFill>
+          <a:ln>
+            <a:noFill/>
+          </a:ln>
+        </p:spPr>
+        <p:style>
+          <a:lnRef idx="1">
+            <a:schemeClr val="accent1"/>
+          </a:lnRef>
+          <a:fillRef idx="3">
+            <a:schemeClr val="accent1"/>
+          </a:fillRef>
+          <a:effectRef idx="2">
+            <a:schemeClr val="accent1"/>
+          </a:effectRef>
+          <a:fontRef idx="minor">
+            <a:schemeClr val="lt1"/>
+          </a:fontRef>
+        </p:style>
+        <p:txBody>
+          <a:bodyPr rtlCol="0" anchor="ctr"/>
+          <a:lstStyle/>
+          <a:p>
+            <a:pPr algn="ctr"/>
+          </a:p>
+        </p:txBody>
+      </p:sp>
+      <p:sp>
+        <p:nvSpPr>
+          <p:cNvPr id="3" name="Rectangle 2"/>
+          <p:cNvSpPr/>
+          <p:nvPr/>
+        </p:nvSpPr>
+        <p:spPr>
+          <a:xfrm>
+            <a:off x="0" y="36576"/>
+            <a:ext cx="12191695" cy="1005840"/>
+          </a:xfrm>
+          <a:prstGeom prst="rect">
+            <a:avLst/>
+          </a:prstGeom>
+          <a:solidFill>
+            <a:srgbClr val="F5F5F5"/>
+          </a:solidFill>
+          <a:ln>
+            <a:noFill/>
+          </a:ln>
+        </p:spPr>
+        <p:style>
+          <a:lnRef idx="1">
+            <a:schemeClr val="accent1"/>
+          </a:lnRef>
+          <a:fillRef idx="3">
+            <a:schemeClr val="accent1"/>
+          </a:fillRef>
+          <a:effectRef idx="2">
+            <a:schemeClr val="accent1"/>
+          </a:effectRef>
+          <a:fontRef idx="minor">
+            <a:schemeClr val="lt1"/>
+          </a:fontRef>
+        </p:style>
+        <p:txBody>
+          <a:bodyPr rtlCol="0" anchor="ctr"/>
+          <a:lstStyle/>
+          <a:p>
+            <a:pPr algn="ctr"/>
+          </a:p>
+        </p:txBody>
+      </p:sp>
+      <p:sp>
+        <p:nvSpPr>
+          <p:cNvPr id="4" name="TextBox 3"/>
           <p:cNvSpPr txBox="1"/>
           <p:nvPr/>
         </p:nvSpPr>
         <p:spPr>
           <a:xfrm>
-            <a:off x="457200" y="365760"/>
-            <a:ext cx="11247120" cy="822960"/>
+            <a:off x="640080" y="164592"/>
+            <a:ext cx="10515600" cy="731520"/>
           </a:xfrm>
           <a:prstGeom prst="rect">
             <a:avLst/>
@@ -3218,18 +3653,191 @@
           <a:noFill/>
         </p:spPr>
         <p:txBody>
-          <a:bodyPr wrap="none">
-            <a:spAutoFit/>
-          </a:bodyPr>
-          <a:lstStyle/>
-          <a:p>
-            <a:r>
-              <a:rPr sz="2400" b="1">
+          <a:bodyPr wrap="square"/>
+          <a:lstStyle/>
+          <a:p>
+            <a:pPr algn="l">
+              <a:spcBef>
+                <a:spcPts val="0"/>
+              </a:spcBef>
+              <a:spcAft>
+                <a:spcPts val="0"/>
+              </a:spcAft>
+            </a:pPr>
+            <a:r>
+              <a:rPr sz="2200" b="1">
                 <a:solidFill>
-                  <a:srgbClr val="0B3D91"/>
+                  <a:srgbClr val="111111"/>
                 </a:solidFill>
+                <a:latin typeface="Calibri"/>
               </a:rPr>
               <a:t>[11/12] Méthodologie</a:t>
+            </a:r>
+          </a:p>
+        </p:txBody>
+      </p:sp>
+      <p:sp>
+        <p:nvSpPr>
+          <p:cNvPr id="5" name="Rectangle 4"/>
+          <p:cNvSpPr/>
+          <p:nvPr/>
+        </p:nvSpPr>
+        <p:spPr>
+          <a:xfrm>
+            <a:off x="640080" y="1042415"/>
+            <a:ext cx="10058400" cy="18288"/>
+          </a:xfrm>
+          <a:prstGeom prst="rect">
+            <a:avLst/>
+          </a:prstGeom>
+          <a:solidFill>
+            <a:srgbClr val="9CA3AF"/>
+          </a:solidFill>
+          <a:ln>
+            <a:noFill/>
+          </a:ln>
+        </p:spPr>
+        <p:style>
+          <a:lnRef idx="1">
+            <a:schemeClr val="accent1"/>
+          </a:lnRef>
+          <a:fillRef idx="3">
+            <a:schemeClr val="accent1"/>
+          </a:fillRef>
+          <a:effectRef idx="2">
+            <a:schemeClr val="accent1"/>
+          </a:effectRef>
+          <a:fontRef idx="minor">
+            <a:schemeClr val="lt1"/>
+          </a:fontRef>
+        </p:style>
+        <p:txBody>
+          <a:bodyPr rtlCol="0" anchor="ctr"/>
+          <a:lstStyle/>
+          <a:p>
+            <a:pPr algn="ctr"/>
+          </a:p>
+        </p:txBody>
+      </p:sp>
+      <p:sp>
+        <p:nvSpPr>
+          <p:cNvPr id="6" name="Rectangle 5"/>
+          <p:cNvSpPr/>
+          <p:nvPr/>
+        </p:nvSpPr>
+        <p:spPr>
+          <a:xfrm>
+            <a:off x="640080" y="6446520"/>
+            <a:ext cx="10515600" cy="9144"/>
+          </a:xfrm>
+          <a:prstGeom prst="rect">
+            <a:avLst/>
+          </a:prstGeom>
+          <a:solidFill>
+            <a:srgbClr val="9CA3AF"/>
+          </a:solidFill>
+          <a:ln>
+            <a:noFill/>
+          </a:ln>
+        </p:spPr>
+        <p:style>
+          <a:lnRef idx="1">
+            <a:schemeClr val="accent1"/>
+          </a:lnRef>
+          <a:fillRef idx="3">
+            <a:schemeClr val="accent1"/>
+          </a:fillRef>
+          <a:effectRef idx="2">
+            <a:schemeClr val="accent1"/>
+          </a:effectRef>
+          <a:fontRef idx="minor">
+            <a:schemeClr val="lt1"/>
+          </a:fontRef>
+        </p:style>
+        <p:txBody>
+          <a:bodyPr rtlCol="0" anchor="ctr"/>
+          <a:lstStyle/>
+          <a:p>
+            <a:pPr algn="ctr"/>
+          </a:p>
+        </p:txBody>
+      </p:sp>
+      <p:sp>
+        <p:nvSpPr>
+          <p:cNvPr id="7" name="TextBox 6"/>
+          <p:cNvSpPr txBox="1"/>
+          <p:nvPr/>
+        </p:nvSpPr>
+        <p:spPr>
+          <a:xfrm>
+            <a:off x="11155680" y="6492240"/>
+            <a:ext cx="731520" cy="274320"/>
+          </a:xfrm>
+          <a:prstGeom prst="rect">
+            <a:avLst/>
+          </a:prstGeom>
+          <a:noFill/>
+        </p:spPr>
+        <p:txBody>
+          <a:bodyPr wrap="square"/>
+          <a:lstStyle/>
+          <a:p>
+            <a:pPr algn="r">
+              <a:spcBef>
+                <a:spcPts val="0"/>
+              </a:spcBef>
+              <a:spcAft>
+                <a:spcPts val="0"/>
+              </a:spcAft>
+            </a:pPr>
+            <a:r>
+              <a:rPr sz="900" b="0">
+                <a:solidFill>
+                  <a:srgbClr val="9CA3AF"/>
+                </a:solidFill>
+                <a:latin typeface="Calibri"/>
+              </a:rPr>
+              <a:t>11/12</a:t>
+            </a:r>
+          </a:p>
+        </p:txBody>
+      </p:sp>
+      <p:sp>
+        <p:nvSpPr>
+          <p:cNvPr id="8" name="TextBox 7"/>
+          <p:cNvSpPr txBox="1"/>
+          <p:nvPr/>
+        </p:nvSpPr>
+        <p:spPr>
+          <a:xfrm>
+            <a:off x="640080" y="6492240"/>
+            <a:ext cx="2743200" cy="274320"/>
+          </a:xfrm>
+          <a:prstGeom prst="rect">
+            <a:avLst/>
+          </a:prstGeom>
+          <a:noFill/>
+        </p:spPr>
+        <p:txBody>
+          <a:bodyPr wrap="square"/>
+          <a:lstStyle/>
+          <a:p>
+            <a:pPr algn="l">
+              <a:spcBef>
+                <a:spcPts val="0"/>
+              </a:spcBef>
+              <a:spcAft>
+                <a:spcPts val="0"/>
+              </a:spcAft>
+            </a:pPr>
+            <a:r>
+              <a:rPr sz="800" b="0">
+                <a:solidFill>
+                  <a:srgbClr val="9CA3AF"/>
+                </a:solidFill>
+                <a:latin typeface="Calibri"/>
+              </a:rPr>
+              <a:t>CONFIDENTIEL</a:t>
             </a:r>
           </a:p>
         </p:txBody>
@@ -3254,14 +3862,100 @@
       <p:grpSpPr/>
       <p:sp>
         <p:nvSpPr>
-          <p:cNvPr id="2" name="TextBox 1"/>
+          <p:cNvPr id="2" name="Rectangle 1"/>
+          <p:cNvSpPr/>
+          <p:nvPr/>
+        </p:nvSpPr>
+        <p:spPr>
+          <a:xfrm>
+            <a:off x="0" y="0"/>
+            <a:ext cx="12191695" cy="36576"/>
+          </a:xfrm>
+          <a:prstGeom prst="rect">
+            <a:avLst/>
+          </a:prstGeom>
+          <a:solidFill>
+            <a:srgbClr val="E63946"/>
+          </a:solidFill>
+          <a:ln>
+            <a:noFill/>
+          </a:ln>
+        </p:spPr>
+        <p:style>
+          <a:lnRef idx="1">
+            <a:schemeClr val="accent1"/>
+          </a:lnRef>
+          <a:fillRef idx="3">
+            <a:schemeClr val="accent1"/>
+          </a:fillRef>
+          <a:effectRef idx="2">
+            <a:schemeClr val="accent1"/>
+          </a:effectRef>
+          <a:fontRef idx="minor">
+            <a:schemeClr val="lt1"/>
+          </a:fontRef>
+        </p:style>
+        <p:txBody>
+          <a:bodyPr rtlCol="0" anchor="ctr"/>
+          <a:lstStyle/>
+          <a:p>
+            <a:pPr algn="ctr"/>
+          </a:p>
+        </p:txBody>
+      </p:sp>
+      <p:sp>
+        <p:nvSpPr>
+          <p:cNvPr id="3" name="Rectangle 2"/>
+          <p:cNvSpPr/>
+          <p:nvPr/>
+        </p:nvSpPr>
+        <p:spPr>
+          <a:xfrm>
+            <a:off x="0" y="36576"/>
+            <a:ext cx="12191695" cy="1005840"/>
+          </a:xfrm>
+          <a:prstGeom prst="rect">
+            <a:avLst/>
+          </a:prstGeom>
+          <a:solidFill>
+            <a:srgbClr val="F5F5F5"/>
+          </a:solidFill>
+          <a:ln>
+            <a:noFill/>
+          </a:ln>
+        </p:spPr>
+        <p:style>
+          <a:lnRef idx="1">
+            <a:schemeClr val="accent1"/>
+          </a:lnRef>
+          <a:fillRef idx="3">
+            <a:schemeClr val="accent1"/>
+          </a:fillRef>
+          <a:effectRef idx="2">
+            <a:schemeClr val="accent1"/>
+          </a:effectRef>
+          <a:fontRef idx="minor">
+            <a:schemeClr val="lt1"/>
+          </a:fontRef>
+        </p:style>
+        <p:txBody>
+          <a:bodyPr rtlCol="0" anchor="ctr"/>
+          <a:lstStyle/>
+          <a:p>
+            <a:pPr algn="ctr"/>
+          </a:p>
+        </p:txBody>
+      </p:sp>
+      <p:sp>
+        <p:nvSpPr>
+          <p:cNvPr id="4" name="TextBox 3"/>
           <p:cNvSpPr txBox="1"/>
           <p:nvPr/>
         </p:nvSpPr>
         <p:spPr>
           <a:xfrm>
-            <a:off x="457200" y="365760"/>
-            <a:ext cx="11247120" cy="822960"/>
+            <a:off x="640080" y="164592"/>
+            <a:ext cx="10515600" cy="731520"/>
           </a:xfrm>
           <a:prstGeom prst="rect">
             <a:avLst/>
@@ -3269,18 +3963,191 @@
           <a:noFill/>
         </p:spPr>
         <p:txBody>
-          <a:bodyPr wrap="none">
-            <a:spAutoFit/>
-          </a:bodyPr>
-          <a:lstStyle/>
-          <a:p>
-            <a:r>
-              <a:rPr sz="2400" b="1">
+          <a:bodyPr wrap="square"/>
+          <a:lstStyle/>
+          <a:p>
+            <a:pPr algn="l">
+              <a:spcBef>
+                <a:spcPts val="0"/>
+              </a:spcBef>
+              <a:spcAft>
+                <a:spcPts val="0"/>
+              </a:spcAft>
+            </a:pPr>
+            <a:r>
+              <a:rPr sz="2200" b="1">
                 <a:solidFill>
-                  <a:srgbClr val="0B3D91"/>
+                  <a:srgbClr val="111111"/>
                 </a:solidFill>
+                <a:latin typeface="Calibri"/>
               </a:rPr>
               <a:t>[12/12] Dataset</a:t>
+            </a:r>
+          </a:p>
+        </p:txBody>
+      </p:sp>
+      <p:sp>
+        <p:nvSpPr>
+          <p:cNvPr id="5" name="Rectangle 4"/>
+          <p:cNvSpPr/>
+          <p:nvPr/>
+        </p:nvSpPr>
+        <p:spPr>
+          <a:xfrm>
+            <a:off x="640080" y="1042415"/>
+            <a:ext cx="10058400" cy="18288"/>
+          </a:xfrm>
+          <a:prstGeom prst="rect">
+            <a:avLst/>
+          </a:prstGeom>
+          <a:solidFill>
+            <a:srgbClr val="9CA3AF"/>
+          </a:solidFill>
+          <a:ln>
+            <a:noFill/>
+          </a:ln>
+        </p:spPr>
+        <p:style>
+          <a:lnRef idx="1">
+            <a:schemeClr val="accent1"/>
+          </a:lnRef>
+          <a:fillRef idx="3">
+            <a:schemeClr val="accent1"/>
+          </a:fillRef>
+          <a:effectRef idx="2">
+            <a:schemeClr val="accent1"/>
+          </a:effectRef>
+          <a:fontRef idx="minor">
+            <a:schemeClr val="lt1"/>
+          </a:fontRef>
+        </p:style>
+        <p:txBody>
+          <a:bodyPr rtlCol="0" anchor="ctr"/>
+          <a:lstStyle/>
+          <a:p>
+            <a:pPr algn="ctr"/>
+          </a:p>
+        </p:txBody>
+      </p:sp>
+      <p:sp>
+        <p:nvSpPr>
+          <p:cNvPr id="6" name="Rectangle 5"/>
+          <p:cNvSpPr/>
+          <p:nvPr/>
+        </p:nvSpPr>
+        <p:spPr>
+          <a:xfrm>
+            <a:off x="640080" y="6446520"/>
+            <a:ext cx="10515600" cy="9144"/>
+          </a:xfrm>
+          <a:prstGeom prst="rect">
+            <a:avLst/>
+          </a:prstGeom>
+          <a:solidFill>
+            <a:srgbClr val="9CA3AF"/>
+          </a:solidFill>
+          <a:ln>
+            <a:noFill/>
+          </a:ln>
+        </p:spPr>
+        <p:style>
+          <a:lnRef idx="1">
+            <a:schemeClr val="accent1"/>
+          </a:lnRef>
+          <a:fillRef idx="3">
+            <a:schemeClr val="accent1"/>
+          </a:fillRef>
+          <a:effectRef idx="2">
+            <a:schemeClr val="accent1"/>
+          </a:effectRef>
+          <a:fontRef idx="minor">
+            <a:schemeClr val="lt1"/>
+          </a:fontRef>
+        </p:style>
+        <p:txBody>
+          <a:bodyPr rtlCol="0" anchor="ctr"/>
+          <a:lstStyle/>
+          <a:p>
+            <a:pPr algn="ctr"/>
+          </a:p>
+        </p:txBody>
+      </p:sp>
+      <p:sp>
+        <p:nvSpPr>
+          <p:cNvPr id="7" name="TextBox 6"/>
+          <p:cNvSpPr txBox="1"/>
+          <p:nvPr/>
+        </p:nvSpPr>
+        <p:spPr>
+          <a:xfrm>
+            <a:off x="11155680" y="6492240"/>
+            <a:ext cx="731520" cy="274320"/>
+          </a:xfrm>
+          <a:prstGeom prst="rect">
+            <a:avLst/>
+          </a:prstGeom>
+          <a:noFill/>
+        </p:spPr>
+        <p:txBody>
+          <a:bodyPr wrap="square"/>
+          <a:lstStyle/>
+          <a:p>
+            <a:pPr algn="r">
+              <a:spcBef>
+                <a:spcPts val="0"/>
+              </a:spcBef>
+              <a:spcAft>
+                <a:spcPts val="0"/>
+              </a:spcAft>
+            </a:pPr>
+            <a:r>
+              <a:rPr sz="900" b="0">
+                <a:solidFill>
+                  <a:srgbClr val="9CA3AF"/>
+                </a:solidFill>
+                <a:latin typeface="Calibri"/>
+              </a:rPr>
+              <a:t>12/12</a:t>
+            </a:r>
+          </a:p>
+        </p:txBody>
+      </p:sp>
+      <p:sp>
+        <p:nvSpPr>
+          <p:cNvPr id="8" name="TextBox 7"/>
+          <p:cNvSpPr txBox="1"/>
+          <p:nvPr/>
+        </p:nvSpPr>
+        <p:spPr>
+          <a:xfrm>
+            <a:off x="640080" y="6492240"/>
+            <a:ext cx="2743200" cy="274320"/>
+          </a:xfrm>
+          <a:prstGeom prst="rect">
+            <a:avLst/>
+          </a:prstGeom>
+          <a:noFill/>
+        </p:spPr>
+        <p:txBody>
+          <a:bodyPr wrap="square"/>
+          <a:lstStyle/>
+          <a:p>
+            <a:pPr algn="l">
+              <a:spcBef>
+                <a:spcPts val="0"/>
+              </a:spcBef>
+              <a:spcAft>
+                <a:spcPts val="0"/>
+              </a:spcAft>
+            </a:pPr>
+            <a:r>
+              <a:rPr sz="800" b="0">
+                <a:solidFill>
+                  <a:srgbClr val="9CA3AF"/>
+                </a:solidFill>
+                <a:latin typeface="Calibri"/>
+              </a:rPr>
+              <a:t>CONFIDENTIEL</a:t>
             </a:r>
           </a:p>
         </p:txBody>
@@ -3305,14 +4172,100 @@
       <p:grpSpPr/>
       <p:sp>
         <p:nvSpPr>
-          <p:cNvPr id="2" name="TextBox 1"/>
+          <p:cNvPr id="2" name="Rectangle 1"/>
+          <p:cNvSpPr/>
+          <p:nvPr/>
+        </p:nvSpPr>
+        <p:spPr>
+          <a:xfrm>
+            <a:off x="0" y="0"/>
+            <a:ext cx="12191695" cy="36576"/>
+          </a:xfrm>
+          <a:prstGeom prst="rect">
+            <a:avLst/>
+          </a:prstGeom>
+          <a:solidFill>
+            <a:srgbClr val="E63946"/>
+          </a:solidFill>
+          <a:ln>
+            <a:noFill/>
+          </a:ln>
+        </p:spPr>
+        <p:style>
+          <a:lnRef idx="1">
+            <a:schemeClr val="accent1"/>
+          </a:lnRef>
+          <a:fillRef idx="3">
+            <a:schemeClr val="accent1"/>
+          </a:fillRef>
+          <a:effectRef idx="2">
+            <a:schemeClr val="accent1"/>
+          </a:effectRef>
+          <a:fontRef idx="minor">
+            <a:schemeClr val="lt1"/>
+          </a:fontRef>
+        </p:style>
+        <p:txBody>
+          <a:bodyPr rtlCol="0" anchor="ctr"/>
+          <a:lstStyle/>
+          <a:p>
+            <a:pPr algn="ctr"/>
+          </a:p>
+        </p:txBody>
+      </p:sp>
+      <p:sp>
+        <p:nvSpPr>
+          <p:cNvPr id="3" name="Rectangle 2"/>
+          <p:cNvSpPr/>
+          <p:nvPr/>
+        </p:nvSpPr>
+        <p:spPr>
+          <a:xfrm>
+            <a:off x="0" y="36576"/>
+            <a:ext cx="12191695" cy="1005840"/>
+          </a:xfrm>
+          <a:prstGeom prst="rect">
+            <a:avLst/>
+          </a:prstGeom>
+          <a:solidFill>
+            <a:srgbClr val="F5F5F5"/>
+          </a:solidFill>
+          <a:ln>
+            <a:noFill/>
+          </a:ln>
+        </p:spPr>
+        <p:style>
+          <a:lnRef idx="1">
+            <a:schemeClr val="accent1"/>
+          </a:lnRef>
+          <a:fillRef idx="3">
+            <a:schemeClr val="accent1"/>
+          </a:fillRef>
+          <a:effectRef idx="2">
+            <a:schemeClr val="accent1"/>
+          </a:effectRef>
+          <a:fontRef idx="minor">
+            <a:schemeClr val="lt1"/>
+          </a:fontRef>
+        </p:style>
+        <p:txBody>
+          <a:bodyPr rtlCol="0" anchor="ctr"/>
+          <a:lstStyle/>
+          <a:p>
+            <a:pPr algn="ctr"/>
+          </a:p>
+        </p:txBody>
+      </p:sp>
+      <p:sp>
+        <p:nvSpPr>
+          <p:cNvPr id="4" name="TextBox 3"/>
           <p:cNvSpPr txBox="1"/>
           <p:nvPr/>
         </p:nvSpPr>
         <p:spPr>
           <a:xfrm>
-            <a:off x="457200" y="365760"/>
-            <a:ext cx="11247120" cy="822960"/>
+            <a:off x="640080" y="164592"/>
+            <a:ext cx="10515600" cy="731520"/>
           </a:xfrm>
           <a:prstGeom prst="rect">
             <a:avLst/>
@@ -3320,18 +4273,191 @@
           <a:noFill/>
         </p:spPr>
         <p:txBody>
-          <a:bodyPr wrap="none">
-            <a:spAutoFit/>
-          </a:bodyPr>
-          <a:lstStyle/>
-          <a:p>
-            <a:r>
-              <a:rPr sz="2400" b="1">
+          <a:bodyPr wrap="square"/>
+          <a:lstStyle/>
+          <a:p>
+            <a:pPr algn="l">
+              <a:spcBef>
+                <a:spcPts val="0"/>
+              </a:spcBef>
+              <a:spcAft>
+                <a:spcPts val="0"/>
+              </a:spcAft>
+            </a:pPr>
+            <a:r>
+              <a:rPr sz="2200" b="1">
                 <a:solidFill>
-                  <a:srgbClr val="0B3D91"/>
+                  <a:srgbClr val="111111"/>
                 </a:solidFill>
+                <a:latin typeface="Calibri"/>
               </a:rPr>
               <a:t>[2/12] Key insight</a:t>
+            </a:r>
+          </a:p>
+        </p:txBody>
+      </p:sp>
+      <p:sp>
+        <p:nvSpPr>
+          <p:cNvPr id="5" name="Rectangle 4"/>
+          <p:cNvSpPr/>
+          <p:nvPr/>
+        </p:nvSpPr>
+        <p:spPr>
+          <a:xfrm>
+            <a:off x="640080" y="1042415"/>
+            <a:ext cx="10058400" cy="18288"/>
+          </a:xfrm>
+          <a:prstGeom prst="rect">
+            <a:avLst/>
+          </a:prstGeom>
+          <a:solidFill>
+            <a:srgbClr val="9CA3AF"/>
+          </a:solidFill>
+          <a:ln>
+            <a:noFill/>
+          </a:ln>
+        </p:spPr>
+        <p:style>
+          <a:lnRef idx="1">
+            <a:schemeClr val="accent1"/>
+          </a:lnRef>
+          <a:fillRef idx="3">
+            <a:schemeClr val="accent1"/>
+          </a:fillRef>
+          <a:effectRef idx="2">
+            <a:schemeClr val="accent1"/>
+          </a:effectRef>
+          <a:fontRef idx="minor">
+            <a:schemeClr val="lt1"/>
+          </a:fontRef>
+        </p:style>
+        <p:txBody>
+          <a:bodyPr rtlCol="0" anchor="ctr"/>
+          <a:lstStyle/>
+          <a:p>
+            <a:pPr algn="ctr"/>
+          </a:p>
+        </p:txBody>
+      </p:sp>
+      <p:sp>
+        <p:nvSpPr>
+          <p:cNvPr id="6" name="Rectangle 5"/>
+          <p:cNvSpPr/>
+          <p:nvPr/>
+        </p:nvSpPr>
+        <p:spPr>
+          <a:xfrm>
+            <a:off x="640080" y="6446520"/>
+            <a:ext cx="10515600" cy="9144"/>
+          </a:xfrm>
+          <a:prstGeom prst="rect">
+            <a:avLst/>
+          </a:prstGeom>
+          <a:solidFill>
+            <a:srgbClr val="9CA3AF"/>
+          </a:solidFill>
+          <a:ln>
+            <a:noFill/>
+          </a:ln>
+        </p:spPr>
+        <p:style>
+          <a:lnRef idx="1">
+            <a:schemeClr val="accent1"/>
+          </a:lnRef>
+          <a:fillRef idx="3">
+            <a:schemeClr val="accent1"/>
+          </a:fillRef>
+          <a:effectRef idx="2">
+            <a:schemeClr val="accent1"/>
+          </a:effectRef>
+          <a:fontRef idx="minor">
+            <a:schemeClr val="lt1"/>
+          </a:fontRef>
+        </p:style>
+        <p:txBody>
+          <a:bodyPr rtlCol="0" anchor="ctr"/>
+          <a:lstStyle/>
+          <a:p>
+            <a:pPr algn="ctr"/>
+          </a:p>
+        </p:txBody>
+      </p:sp>
+      <p:sp>
+        <p:nvSpPr>
+          <p:cNvPr id="7" name="TextBox 6"/>
+          <p:cNvSpPr txBox="1"/>
+          <p:nvPr/>
+        </p:nvSpPr>
+        <p:spPr>
+          <a:xfrm>
+            <a:off x="11155680" y="6492240"/>
+            <a:ext cx="731520" cy="274320"/>
+          </a:xfrm>
+          <a:prstGeom prst="rect">
+            <a:avLst/>
+          </a:prstGeom>
+          <a:noFill/>
+        </p:spPr>
+        <p:txBody>
+          <a:bodyPr wrap="square"/>
+          <a:lstStyle/>
+          <a:p>
+            <a:pPr algn="r">
+              <a:spcBef>
+                <a:spcPts val="0"/>
+              </a:spcBef>
+              <a:spcAft>
+                <a:spcPts val="0"/>
+              </a:spcAft>
+            </a:pPr>
+            <a:r>
+              <a:rPr sz="900" b="0">
+                <a:solidFill>
+                  <a:srgbClr val="9CA3AF"/>
+                </a:solidFill>
+                <a:latin typeface="Calibri"/>
+              </a:rPr>
+              <a:t>2/12</a:t>
+            </a:r>
+          </a:p>
+        </p:txBody>
+      </p:sp>
+      <p:sp>
+        <p:nvSpPr>
+          <p:cNvPr id="8" name="TextBox 7"/>
+          <p:cNvSpPr txBox="1"/>
+          <p:nvPr/>
+        </p:nvSpPr>
+        <p:spPr>
+          <a:xfrm>
+            <a:off x="640080" y="6492240"/>
+            <a:ext cx="2743200" cy="274320"/>
+          </a:xfrm>
+          <a:prstGeom prst="rect">
+            <a:avLst/>
+          </a:prstGeom>
+          <a:noFill/>
+        </p:spPr>
+        <p:txBody>
+          <a:bodyPr wrap="square"/>
+          <a:lstStyle/>
+          <a:p>
+            <a:pPr algn="l">
+              <a:spcBef>
+                <a:spcPts val="0"/>
+              </a:spcBef>
+              <a:spcAft>
+                <a:spcPts val="0"/>
+              </a:spcAft>
+            </a:pPr>
+            <a:r>
+              <a:rPr sz="800" b="0">
+                <a:solidFill>
+                  <a:srgbClr val="9CA3AF"/>
+                </a:solidFill>
+                <a:latin typeface="Calibri"/>
+              </a:rPr>
+              <a:t>CONFIDENTIEL</a:t>
             </a:r>
           </a:p>
         </p:txBody>
@@ -3356,14 +4482,100 @@
       <p:grpSpPr/>
       <p:sp>
         <p:nvSpPr>
-          <p:cNvPr id="2" name="TextBox 1"/>
+          <p:cNvPr id="2" name="Rectangle 1"/>
+          <p:cNvSpPr/>
+          <p:nvPr/>
+        </p:nvSpPr>
+        <p:spPr>
+          <a:xfrm>
+            <a:off x="0" y="0"/>
+            <a:ext cx="12191695" cy="36576"/>
+          </a:xfrm>
+          <a:prstGeom prst="rect">
+            <a:avLst/>
+          </a:prstGeom>
+          <a:solidFill>
+            <a:srgbClr val="E63946"/>
+          </a:solidFill>
+          <a:ln>
+            <a:noFill/>
+          </a:ln>
+        </p:spPr>
+        <p:style>
+          <a:lnRef idx="1">
+            <a:schemeClr val="accent1"/>
+          </a:lnRef>
+          <a:fillRef idx="3">
+            <a:schemeClr val="accent1"/>
+          </a:fillRef>
+          <a:effectRef idx="2">
+            <a:schemeClr val="accent1"/>
+          </a:effectRef>
+          <a:fontRef idx="minor">
+            <a:schemeClr val="lt1"/>
+          </a:fontRef>
+        </p:style>
+        <p:txBody>
+          <a:bodyPr rtlCol="0" anchor="ctr"/>
+          <a:lstStyle/>
+          <a:p>
+            <a:pPr algn="ctr"/>
+          </a:p>
+        </p:txBody>
+      </p:sp>
+      <p:sp>
+        <p:nvSpPr>
+          <p:cNvPr id="3" name="Rectangle 2"/>
+          <p:cNvSpPr/>
+          <p:nvPr/>
+        </p:nvSpPr>
+        <p:spPr>
+          <a:xfrm>
+            <a:off x="0" y="36576"/>
+            <a:ext cx="12191695" cy="1005840"/>
+          </a:xfrm>
+          <a:prstGeom prst="rect">
+            <a:avLst/>
+          </a:prstGeom>
+          <a:solidFill>
+            <a:srgbClr val="F5F5F5"/>
+          </a:solidFill>
+          <a:ln>
+            <a:noFill/>
+          </a:ln>
+        </p:spPr>
+        <p:style>
+          <a:lnRef idx="1">
+            <a:schemeClr val="accent1"/>
+          </a:lnRef>
+          <a:fillRef idx="3">
+            <a:schemeClr val="accent1"/>
+          </a:fillRef>
+          <a:effectRef idx="2">
+            <a:schemeClr val="accent1"/>
+          </a:effectRef>
+          <a:fontRef idx="minor">
+            <a:schemeClr val="lt1"/>
+          </a:fontRef>
+        </p:style>
+        <p:txBody>
+          <a:bodyPr rtlCol="0" anchor="ctr"/>
+          <a:lstStyle/>
+          <a:p>
+            <a:pPr algn="ctr"/>
+          </a:p>
+        </p:txBody>
+      </p:sp>
+      <p:sp>
+        <p:nvSpPr>
+          <p:cNvPr id="4" name="TextBox 3"/>
           <p:cNvSpPr txBox="1"/>
           <p:nvPr/>
         </p:nvSpPr>
         <p:spPr>
           <a:xfrm>
-            <a:off x="457200" y="365760"/>
-            <a:ext cx="11247120" cy="822960"/>
+            <a:off x="640080" y="164592"/>
+            <a:ext cx="10515600" cy="731520"/>
           </a:xfrm>
           <a:prstGeom prst="rect">
             <a:avLst/>
@@ -3371,18 +4583,191 @@
           <a:noFill/>
         </p:spPr>
         <p:txBody>
-          <a:bodyPr wrap="none">
-            <a:spAutoFit/>
-          </a:bodyPr>
-          <a:lstStyle/>
-          <a:p>
-            <a:r>
-              <a:rPr sz="2400" b="1">
+          <a:bodyPr wrap="square"/>
+          <a:lstStyle/>
+          <a:p>
+            <a:pPr algn="l">
+              <a:spcBef>
+                <a:spcPts val="0"/>
+              </a:spcBef>
+              <a:spcAft>
+                <a:spcPts val="0"/>
+              </a:spcAft>
+            </a:pPr>
+            <a:r>
+              <a:rPr sz="2200" b="1">
                 <a:solidFill>
-                  <a:srgbClr val="0B3D91"/>
+                  <a:srgbClr val="111111"/>
                 </a:solidFill>
+                <a:latin typeface="Calibri"/>
               </a:rPr>
               <a:t>[3/12] Chart 1</a:t>
+            </a:r>
+          </a:p>
+        </p:txBody>
+      </p:sp>
+      <p:sp>
+        <p:nvSpPr>
+          <p:cNvPr id="5" name="Rectangle 4"/>
+          <p:cNvSpPr/>
+          <p:nvPr/>
+        </p:nvSpPr>
+        <p:spPr>
+          <a:xfrm>
+            <a:off x="640080" y="1042415"/>
+            <a:ext cx="10058400" cy="18288"/>
+          </a:xfrm>
+          <a:prstGeom prst="rect">
+            <a:avLst/>
+          </a:prstGeom>
+          <a:solidFill>
+            <a:srgbClr val="9CA3AF"/>
+          </a:solidFill>
+          <a:ln>
+            <a:noFill/>
+          </a:ln>
+        </p:spPr>
+        <p:style>
+          <a:lnRef idx="1">
+            <a:schemeClr val="accent1"/>
+          </a:lnRef>
+          <a:fillRef idx="3">
+            <a:schemeClr val="accent1"/>
+          </a:fillRef>
+          <a:effectRef idx="2">
+            <a:schemeClr val="accent1"/>
+          </a:effectRef>
+          <a:fontRef idx="minor">
+            <a:schemeClr val="lt1"/>
+          </a:fontRef>
+        </p:style>
+        <p:txBody>
+          <a:bodyPr rtlCol="0" anchor="ctr"/>
+          <a:lstStyle/>
+          <a:p>
+            <a:pPr algn="ctr"/>
+          </a:p>
+        </p:txBody>
+      </p:sp>
+      <p:sp>
+        <p:nvSpPr>
+          <p:cNvPr id="6" name="Rectangle 5"/>
+          <p:cNvSpPr/>
+          <p:nvPr/>
+        </p:nvSpPr>
+        <p:spPr>
+          <a:xfrm>
+            <a:off x="640080" y="6446520"/>
+            <a:ext cx="10515600" cy="9144"/>
+          </a:xfrm>
+          <a:prstGeom prst="rect">
+            <a:avLst/>
+          </a:prstGeom>
+          <a:solidFill>
+            <a:srgbClr val="9CA3AF"/>
+          </a:solidFill>
+          <a:ln>
+            <a:noFill/>
+          </a:ln>
+        </p:spPr>
+        <p:style>
+          <a:lnRef idx="1">
+            <a:schemeClr val="accent1"/>
+          </a:lnRef>
+          <a:fillRef idx="3">
+            <a:schemeClr val="accent1"/>
+          </a:fillRef>
+          <a:effectRef idx="2">
+            <a:schemeClr val="accent1"/>
+          </a:effectRef>
+          <a:fontRef idx="minor">
+            <a:schemeClr val="lt1"/>
+          </a:fontRef>
+        </p:style>
+        <p:txBody>
+          <a:bodyPr rtlCol="0" anchor="ctr"/>
+          <a:lstStyle/>
+          <a:p>
+            <a:pPr algn="ctr"/>
+          </a:p>
+        </p:txBody>
+      </p:sp>
+      <p:sp>
+        <p:nvSpPr>
+          <p:cNvPr id="7" name="TextBox 6"/>
+          <p:cNvSpPr txBox="1"/>
+          <p:nvPr/>
+        </p:nvSpPr>
+        <p:spPr>
+          <a:xfrm>
+            <a:off x="11155680" y="6492240"/>
+            <a:ext cx="731520" cy="274320"/>
+          </a:xfrm>
+          <a:prstGeom prst="rect">
+            <a:avLst/>
+          </a:prstGeom>
+          <a:noFill/>
+        </p:spPr>
+        <p:txBody>
+          <a:bodyPr wrap="square"/>
+          <a:lstStyle/>
+          <a:p>
+            <a:pPr algn="r">
+              <a:spcBef>
+                <a:spcPts val="0"/>
+              </a:spcBef>
+              <a:spcAft>
+                <a:spcPts val="0"/>
+              </a:spcAft>
+            </a:pPr>
+            <a:r>
+              <a:rPr sz="900" b="0">
+                <a:solidFill>
+                  <a:srgbClr val="9CA3AF"/>
+                </a:solidFill>
+                <a:latin typeface="Calibri"/>
+              </a:rPr>
+              <a:t>3/12</a:t>
+            </a:r>
+          </a:p>
+        </p:txBody>
+      </p:sp>
+      <p:sp>
+        <p:nvSpPr>
+          <p:cNvPr id="8" name="TextBox 7"/>
+          <p:cNvSpPr txBox="1"/>
+          <p:nvPr/>
+        </p:nvSpPr>
+        <p:spPr>
+          <a:xfrm>
+            <a:off x="640080" y="6492240"/>
+            <a:ext cx="2743200" cy="274320"/>
+          </a:xfrm>
+          <a:prstGeom prst="rect">
+            <a:avLst/>
+          </a:prstGeom>
+          <a:noFill/>
+        </p:spPr>
+        <p:txBody>
+          <a:bodyPr wrap="square"/>
+          <a:lstStyle/>
+          <a:p>
+            <a:pPr algn="l">
+              <a:spcBef>
+                <a:spcPts val="0"/>
+              </a:spcBef>
+              <a:spcAft>
+                <a:spcPts val="0"/>
+              </a:spcAft>
+            </a:pPr>
+            <a:r>
+              <a:rPr sz="800" b="0">
+                <a:solidFill>
+                  <a:srgbClr val="9CA3AF"/>
+                </a:solidFill>
+                <a:latin typeface="Calibri"/>
+              </a:rPr>
+              <a:t>CONFIDENTIEL</a:t>
             </a:r>
           </a:p>
         </p:txBody>
@@ -3407,14 +4792,100 @@
       <p:grpSpPr/>
       <p:sp>
         <p:nvSpPr>
-          <p:cNvPr id="2" name="TextBox 1"/>
+          <p:cNvPr id="2" name="Rectangle 1"/>
+          <p:cNvSpPr/>
+          <p:nvPr/>
+        </p:nvSpPr>
+        <p:spPr>
+          <a:xfrm>
+            <a:off x="0" y="0"/>
+            <a:ext cx="12191695" cy="36576"/>
+          </a:xfrm>
+          <a:prstGeom prst="rect">
+            <a:avLst/>
+          </a:prstGeom>
+          <a:solidFill>
+            <a:srgbClr val="E63946"/>
+          </a:solidFill>
+          <a:ln>
+            <a:noFill/>
+          </a:ln>
+        </p:spPr>
+        <p:style>
+          <a:lnRef idx="1">
+            <a:schemeClr val="accent1"/>
+          </a:lnRef>
+          <a:fillRef idx="3">
+            <a:schemeClr val="accent1"/>
+          </a:fillRef>
+          <a:effectRef idx="2">
+            <a:schemeClr val="accent1"/>
+          </a:effectRef>
+          <a:fontRef idx="minor">
+            <a:schemeClr val="lt1"/>
+          </a:fontRef>
+        </p:style>
+        <p:txBody>
+          <a:bodyPr rtlCol="0" anchor="ctr"/>
+          <a:lstStyle/>
+          <a:p>
+            <a:pPr algn="ctr"/>
+          </a:p>
+        </p:txBody>
+      </p:sp>
+      <p:sp>
+        <p:nvSpPr>
+          <p:cNvPr id="3" name="Rectangle 2"/>
+          <p:cNvSpPr/>
+          <p:nvPr/>
+        </p:nvSpPr>
+        <p:spPr>
+          <a:xfrm>
+            <a:off x="0" y="36576"/>
+            <a:ext cx="12191695" cy="1005840"/>
+          </a:xfrm>
+          <a:prstGeom prst="rect">
+            <a:avLst/>
+          </a:prstGeom>
+          <a:solidFill>
+            <a:srgbClr val="F5F5F5"/>
+          </a:solidFill>
+          <a:ln>
+            <a:noFill/>
+          </a:ln>
+        </p:spPr>
+        <p:style>
+          <a:lnRef idx="1">
+            <a:schemeClr val="accent1"/>
+          </a:lnRef>
+          <a:fillRef idx="3">
+            <a:schemeClr val="accent1"/>
+          </a:fillRef>
+          <a:effectRef idx="2">
+            <a:schemeClr val="accent1"/>
+          </a:effectRef>
+          <a:fontRef idx="minor">
+            <a:schemeClr val="lt1"/>
+          </a:fontRef>
+        </p:style>
+        <p:txBody>
+          <a:bodyPr rtlCol="0" anchor="ctr"/>
+          <a:lstStyle/>
+          <a:p>
+            <a:pPr algn="ctr"/>
+          </a:p>
+        </p:txBody>
+      </p:sp>
+      <p:sp>
+        <p:nvSpPr>
+          <p:cNvPr id="4" name="TextBox 3"/>
           <p:cNvSpPr txBox="1"/>
           <p:nvPr/>
         </p:nvSpPr>
         <p:spPr>
           <a:xfrm>
-            <a:off x="457200" y="365760"/>
-            <a:ext cx="11247120" cy="822960"/>
+            <a:off x="640080" y="164592"/>
+            <a:ext cx="10515600" cy="731520"/>
           </a:xfrm>
           <a:prstGeom prst="rect">
             <a:avLst/>
@@ -3422,18 +4893,191 @@
           <a:noFill/>
         </p:spPr>
         <p:txBody>
-          <a:bodyPr wrap="none">
-            <a:spAutoFit/>
-          </a:bodyPr>
-          <a:lstStyle/>
-          <a:p>
-            <a:r>
-              <a:rPr sz="2400" b="1">
+          <a:bodyPr wrap="square"/>
+          <a:lstStyle/>
+          <a:p>
+            <a:pPr algn="l">
+              <a:spcBef>
+                <a:spcPts val="0"/>
+              </a:spcBef>
+              <a:spcAft>
+                <a:spcPts val="0"/>
+              </a:spcAft>
+            </a:pPr>
+            <a:r>
+              <a:rPr sz="2200" b="1">
                 <a:solidFill>
-                  <a:srgbClr val="0B3D91"/>
+                  <a:srgbClr val="111111"/>
                 </a:solidFill>
+                <a:latin typeface="Calibri"/>
               </a:rPr>
               <a:t>[4/12] Chart 2</a:t>
+            </a:r>
+          </a:p>
+        </p:txBody>
+      </p:sp>
+      <p:sp>
+        <p:nvSpPr>
+          <p:cNvPr id="5" name="Rectangle 4"/>
+          <p:cNvSpPr/>
+          <p:nvPr/>
+        </p:nvSpPr>
+        <p:spPr>
+          <a:xfrm>
+            <a:off x="640080" y="1042415"/>
+            <a:ext cx="10058400" cy="18288"/>
+          </a:xfrm>
+          <a:prstGeom prst="rect">
+            <a:avLst/>
+          </a:prstGeom>
+          <a:solidFill>
+            <a:srgbClr val="9CA3AF"/>
+          </a:solidFill>
+          <a:ln>
+            <a:noFill/>
+          </a:ln>
+        </p:spPr>
+        <p:style>
+          <a:lnRef idx="1">
+            <a:schemeClr val="accent1"/>
+          </a:lnRef>
+          <a:fillRef idx="3">
+            <a:schemeClr val="accent1"/>
+          </a:fillRef>
+          <a:effectRef idx="2">
+            <a:schemeClr val="accent1"/>
+          </a:effectRef>
+          <a:fontRef idx="minor">
+            <a:schemeClr val="lt1"/>
+          </a:fontRef>
+        </p:style>
+        <p:txBody>
+          <a:bodyPr rtlCol="0" anchor="ctr"/>
+          <a:lstStyle/>
+          <a:p>
+            <a:pPr algn="ctr"/>
+          </a:p>
+        </p:txBody>
+      </p:sp>
+      <p:sp>
+        <p:nvSpPr>
+          <p:cNvPr id="6" name="Rectangle 5"/>
+          <p:cNvSpPr/>
+          <p:nvPr/>
+        </p:nvSpPr>
+        <p:spPr>
+          <a:xfrm>
+            <a:off x="640080" y="6446520"/>
+            <a:ext cx="10515600" cy="9144"/>
+          </a:xfrm>
+          <a:prstGeom prst="rect">
+            <a:avLst/>
+          </a:prstGeom>
+          <a:solidFill>
+            <a:srgbClr val="9CA3AF"/>
+          </a:solidFill>
+          <a:ln>
+            <a:noFill/>
+          </a:ln>
+        </p:spPr>
+        <p:style>
+          <a:lnRef idx="1">
+            <a:schemeClr val="accent1"/>
+          </a:lnRef>
+          <a:fillRef idx="3">
+            <a:schemeClr val="accent1"/>
+          </a:fillRef>
+          <a:effectRef idx="2">
+            <a:schemeClr val="accent1"/>
+          </a:effectRef>
+          <a:fontRef idx="minor">
+            <a:schemeClr val="lt1"/>
+          </a:fontRef>
+        </p:style>
+        <p:txBody>
+          <a:bodyPr rtlCol="0" anchor="ctr"/>
+          <a:lstStyle/>
+          <a:p>
+            <a:pPr algn="ctr"/>
+          </a:p>
+        </p:txBody>
+      </p:sp>
+      <p:sp>
+        <p:nvSpPr>
+          <p:cNvPr id="7" name="TextBox 6"/>
+          <p:cNvSpPr txBox="1"/>
+          <p:nvPr/>
+        </p:nvSpPr>
+        <p:spPr>
+          <a:xfrm>
+            <a:off x="11155680" y="6492240"/>
+            <a:ext cx="731520" cy="274320"/>
+          </a:xfrm>
+          <a:prstGeom prst="rect">
+            <a:avLst/>
+          </a:prstGeom>
+          <a:noFill/>
+        </p:spPr>
+        <p:txBody>
+          <a:bodyPr wrap="square"/>
+          <a:lstStyle/>
+          <a:p>
+            <a:pPr algn="r">
+              <a:spcBef>
+                <a:spcPts val="0"/>
+              </a:spcBef>
+              <a:spcAft>
+                <a:spcPts val="0"/>
+              </a:spcAft>
+            </a:pPr>
+            <a:r>
+              <a:rPr sz="900" b="0">
+                <a:solidFill>
+                  <a:srgbClr val="9CA3AF"/>
+                </a:solidFill>
+                <a:latin typeface="Calibri"/>
+              </a:rPr>
+              <a:t>4/12</a:t>
+            </a:r>
+          </a:p>
+        </p:txBody>
+      </p:sp>
+      <p:sp>
+        <p:nvSpPr>
+          <p:cNvPr id="8" name="TextBox 7"/>
+          <p:cNvSpPr txBox="1"/>
+          <p:nvPr/>
+        </p:nvSpPr>
+        <p:spPr>
+          <a:xfrm>
+            <a:off x="640080" y="6492240"/>
+            <a:ext cx="2743200" cy="274320"/>
+          </a:xfrm>
+          <a:prstGeom prst="rect">
+            <a:avLst/>
+          </a:prstGeom>
+          <a:noFill/>
+        </p:spPr>
+        <p:txBody>
+          <a:bodyPr wrap="square"/>
+          <a:lstStyle/>
+          <a:p>
+            <a:pPr algn="l">
+              <a:spcBef>
+                <a:spcPts val="0"/>
+              </a:spcBef>
+              <a:spcAft>
+                <a:spcPts val="0"/>
+              </a:spcAft>
+            </a:pPr>
+            <a:r>
+              <a:rPr sz="800" b="0">
+                <a:solidFill>
+                  <a:srgbClr val="9CA3AF"/>
+                </a:solidFill>
+                <a:latin typeface="Calibri"/>
+              </a:rPr>
+              <a:t>CONFIDENTIEL</a:t>
             </a:r>
           </a:p>
         </p:txBody>
@@ -3458,14 +5102,100 @@
       <p:grpSpPr/>
       <p:sp>
         <p:nvSpPr>
-          <p:cNvPr id="2" name="TextBox 1"/>
+          <p:cNvPr id="2" name="Rectangle 1"/>
+          <p:cNvSpPr/>
+          <p:nvPr/>
+        </p:nvSpPr>
+        <p:spPr>
+          <a:xfrm>
+            <a:off x="0" y="0"/>
+            <a:ext cx="12191695" cy="36576"/>
+          </a:xfrm>
+          <a:prstGeom prst="rect">
+            <a:avLst/>
+          </a:prstGeom>
+          <a:solidFill>
+            <a:srgbClr val="E63946"/>
+          </a:solidFill>
+          <a:ln>
+            <a:noFill/>
+          </a:ln>
+        </p:spPr>
+        <p:style>
+          <a:lnRef idx="1">
+            <a:schemeClr val="accent1"/>
+          </a:lnRef>
+          <a:fillRef idx="3">
+            <a:schemeClr val="accent1"/>
+          </a:fillRef>
+          <a:effectRef idx="2">
+            <a:schemeClr val="accent1"/>
+          </a:effectRef>
+          <a:fontRef idx="minor">
+            <a:schemeClr val="lt1"/>
+          </a:fontRef>
+        </p:style>
+        <p:txBody>
+          <a:bodyPr rtlCol="0" anchor="ctr"/>
+          <a:lstStyle/>
+          <a:p>
+            <a:pPr algn="ctr"/>
+          </a:p>
+        </p:txBody>
+      </p:sp>
+      <p:sp>
+        <p:nvSpPr>
+          <p:cNvPr id="3" name="Rectangle 2"/>
+          <p:cNvSpPr/>
+          <p:nvPr/>
+        </p:nvSpPr>
+        <p:spPr>
+          <a:xfrm>
+            <a:off x="0" y="36576"/>
+            <a:ext cx="12191695" cy="1005840"/>
+          </a:xfrm>
+          <a:prstGeom prst="rect">
+            <a:avLst/>
+          </a:prstGeom>
+          <a:solidFill>
+            <a:srgbClr val="F5F5F5"/>
+          </a:solidFill>
+          <a:ln>
+            <a:noFill/>
+          </a:ln>
+        </p:spPr>
+        <p:style>
+          <a:lnRef idx="1">
+            <a:schemeClr val="accent1"/>
+          </a:lnRef>
+          <a:fillRef idx="3">
+            <a:schemeClr val="accent1"/>
+          </a:fillRef>
+          <a:effectRef idx="2">
+            <a:schemeClr val="accent1"/>
+          </a:effectRef>
+          <a:fontRef idx="minor">
+            <a:schemeClr val="lt1"/>
+          </a:fontRef>
+        </p:style>
+        <p:txBody>
+          <a:bodyPr rtlCol="0" anchor="ctr"/>
+          <a:lstStyle/>
+          <a:p>
+            <a:pPr algn="ctr"/>
+          </a:p>
+        </p:txBody>
+      </p:sp>
+      <p:sp>
+        <p:nvSpPr>
+          <p:cNvPr id="4" name="TextBox 3"/>
           <p:cNvSpPr txBox="1"/>
           <p:nvPr/>
         </p:nvSpPr>
         <p:spPr>
           <a:xfrm>
-            <a:off x="457200" y="365760"/>
-            <a:ext cx="11247120" cy="822960"/>
+            <a:off x="640080" y="164592"/>
+            <a:ext cx="10515600" cy="731520"/>
           </a:xfrm>
           <a:prstGeom prst="rect">
             <a:avLst/>
@@ -3473,18 +5203,191 @@
           <a:noFill/>
         </p:spPr>
         <p:txBody>
-          <a:bodyPr wrap="none">
-            <a:spAutoFit/>
-          </a:bodyPr>
-          <a:lstStyle/>
-          <a:p>
-            <a:r>
-              <a:rPr sz="2400" b="1">
+          <a:bodyPr wrap="square"/>
+          <a:lstStyle/>
+          <a:p>
+            <a:pPr algn="l">
+              <a:spcBef>
+                <a:spcPts val="0"/>
+              </a:spcBef>
+              <a:spcAft>
+                <a:spcPts val="0"/>
+              </a:spcAft>
+            </a:pPr>
+            <a:r>
+              <a:rPr sz="2200" b="1">
                 <a:solidFill>
-                  <a:srgbClr val="0B3D91"/>
+                  <a:srgbClr val="111111"/>
                 </a:solidFill>
+                <a:latin typeface="Calibri"/>
               </a:rPr>
               <a:t>[5/12] Chart 3</a:t>
+            </a:r>
+          </a:p>
+        </p:txBody>
+      </p:sp>
+      <p:sp>
+        <p:nvSpPr>
+          <p:cNvPr id="5" name="Rectangle 4"/>
+          <p:cNvSpPr/>
+          <p:nvPr/>
+        </p:nvSpPr>
+        <p:spPr>
+          <a:xfrm>
+            <a:off x="640080" y="1042415"/>
+            <a:ext cx="10058400" cy="18288"/>
+          </a:xfrm>
+          <a:prstGeom prst="rect">
+            <a:avLst/>
+          </a:prstGeom>
+          <a:solidFill>
+            <a:srgbClr val="9CA3AF"/>
+          </a:solidFill>
+          <a:ln>
+            <a:noFill/>
+          </a:ln>
+        </p:spPr>
+        <p:style>
+          <a:lnRef idx="1">
+            <a:schemeClr val="accent1"/>
+          </a:lnRef>
+          <a:fillRef idx="3">
+            <a:schemeClr val="accent1"/>
+          </a:fillRef>
+          <a:effectRef idx="2">
+            <a:schemeClr val="accent1"/>
+          </a:effectRef>
+          <a:fontRef idx="minor">
+            <a:schemeClr val="lt1"/>
+          </a:fontRef>
+        </p:style>
+        <p:txBody>
+          <a:bodyPr rtlCol="0" anchor="ctr"/>
+          <a:lstStyle/>
+          <a:p>
+            <a:pPr algn="ctr"/>
+          </a:p>
+        </p:txBody>
+      </p:sp>
+      <p:sp>
+        <p:nvSpPr>
+          <p:cNvPr id="6" name="Rectangle 5"/>
+          <p:cNvSpPr/>
+          <p:nvPr/>
+        </p:nvSpPr>
+        <p:spPr>
+          <a:xfrm>
+            <a:off x="640080" y="6446520"/>
+            <a:ext cx="10515600" cy="9144"/>
+          </a:xfrm>
+          <a:prstGeom prst="rect">
+            <a:avLst/>
+          </a:prstGeom>
+          <a:solidFill>
+            <a:srgbClr val="9CA3AF"/>
+          </a:solidFill>
+          <a:ln>
+            <a:noFill/>
+          </a:ln>
+        </p:spPr>
+        <p:style>
+          <a:lnRef idx="1">
+            <a:schemeClr val="accent1"/>
+          </a:lnRef>
+          <a:fillRef idx="3">
+            <a:schemeClr val="accent1"/>
+          </a:fillRef>
+          <a:effectRef idx="2">
+            <a:schemeClr val="accent1"/>
+          </a:effectRef>
+          <a:fontRef idx="minor">
+            <a:schemeClr val="lt1"/>
+          </a:fontRef>
+        </p:style>
+        <p:txBody>
+          <a:bodyPr rtlCol="0" anchor="ctr"/>
+          <a:lstStyle/>
+          <a:p>
+            <a:pPr algn="ctr"/>
+          </a:p>
+        </p:txBody>
+      </p:sp>
+      <p:sp>
+        <p:nvSpPr>
+          <p:cNvPr id="7" name="TextBox 6"/>
+          <p:cNvSpPr txBox="1"/>
+          <p:nvPr/>
+        </p:nvSpPr>
+        <p:spPr>
+          <a:xfrm>
+            <a:off x="11155680" y="6492240"/>
+            <a:ext cx="731520" cy="274320"/>
+          </a:xfrm>
+          <a:prstGeom prst="rect">
+            <a:avLst/>
+          </a:prstGeom>
+          <a:noFill/>
+        </p:spPr>
+        <p:txBody>
+          <a:bodyPr wrap="square"/>
+          <a:lstStyle/>
+          <a:p>
+            <a:pPr algn="r">
+              <a:spcBef>
+                <a:spcPts val="0"/>
+              </a:spcBef>
+              <a:spcAft>
+                <a:spcPts val="0"/>
+              </a:spcAft>
+            </a:pPr>
+            <a:r>
+              <a:rPr sz="900" b="0">
+                <a:solidFill>
+                  <a:srgbClr val="9CA3AF"/>
+                </a:solidFill>
+                <a:latin typeface="Calibri"/>
+              </a:rPr>
+              <a:t>5/12</a:t>
+            </a:r>
+          </a:p>
+        </p:txBody>
+      </p:sp>
+      <p:sp>
+        <p:nvSpPr>
+          <p:cNvPr id="8" name="TextBox 7"/>
+          <p:cNvSpPr txBox="1"/>
+          <p:nvPr/>
+        </p:nvSpPr>
+        <p:spPr>
+          <a:xfrm>
+            <a:off x="640080" y="6492240"/>
+            <a:ext cx="2743200" cy="274320"/>
+          </a:xfrm>
+          <a:prstGeom prst="rect">
+            <a:avLst/>
+          </a:prstGeom>
+          <a:noFill/>
+        </p:spPr>
+        <p:txBody>
+          <a:bodyPr wrap="square"/>
+          <a:lstStyle/>
+          <a:p>
+            <a:pPr algn="l">
+              <a:spcBef>
+                <a:spcPts val="0"/>
+              </a:spcBef>
+              <a:spcAft>
+                <a:spcPts val="0"/>
+              </a:spcAft>
+            </a:pPr>
+            <a:r>
+              <a:rPr sz="800" b="0">
+                <a:solidFill>
+                  <a:srgbClr val="9CA3AF"/>
+                </a:solidFill>
+                <a:latin typeface="Calibri"/>
+              </a:rPr>
+              <a:t>CONFIDENTIEL</a:t>
             </a:r>
           </a:p>
         </p:txBody>
@@ -3509,14 +5412,100 @@
       <p:grpSpPr/>
       <p:sp>
         <p:nvSpPr>
-          <p:cNvPr id="2" name="TextBox 1"/>
+          <p:cNvPr id="2" name="Rectangle 1"/>
+          <p:cNvSpPr/>
+          <p:nvPr/>
+        </p:nvSpPr>
+        <p:spPr>
+          <a:xfrm>
+            <a:off x="0" y="0"/>
+            <a:ext cx="12191695" cy="36576"/>
+          </a:xfrm>
+          <a:prstGeom prst="rect">
+            <a:avLst/>
+          </a:prstGeom>
+          <a:solidFill>
+            <a:srgbClr val="E63946"/>
+          </a:solidFill>
+          <a:ln>
+            <a:noFill/>
+          </a:ln>
+        </p:spPr>
+        <p:style>
+          <a:lnRef idx="1">
+            <a:schemeClr val="accent1"/>
+          </a:lnRef>
+          <a:fillRef idx="3">
+            <a:schemeClr val="accent1"/>
+          </a:fillRef>
+          <a:effectRef idx="2">
+            <a:schemeClr val="accent1"/>
+          </a:effectRef>
+          <a:fontRef idx="minor">
+            <a:schemeClr val="lt1"/>
+          </a:fontRef>
+        </p:style>
+        <p:txBody>
+          <a:bodyPr rtlCol="0" anchor="ctr"/>
+          <a:lstStyle/>
+          <a:p>
+            <a:pPr algn="ctr"/>
+          </a:p>
+        </p:txBody>
+      </p:sp>
+      <p:sp>
+        <p:nvSpPr>
+          <p:cNvPr id="3" name="Rectangle 2"/>
+          <p:cNvSpPr/>
+          <p:nvPr/>
+        </p:nvSpPr>
+        <p:spPr>
+          <a:xfrm>
+            <a:off x="0" y="36576"/>
+            <a:ext cx="12191695" cy="1005840"/>
+          </a:xfrm>
+          <a:prstGeom prst="rect">
+            <a:avLst/>
+          </a:prstGeom>
+          <a:solidFill>
+            <a:srgbClr val="F5F5F5"/>
+          </a:solidFill>
+          <a:ln>
+            <a:noFill/>
+          </a:ln>
+        </p:spPr>
+        <p:style>
+          <a:lnRef idx="1">
+            <a:schemeClr val="accent1"/>
+          </a:lnRef>
+          <a:fillRef idx="3">
+            <a:schemeClr val="accent1"/>
+          </a:fillRef>
+          <a:effectRef idx="2">
+            <a:schemeClr val="accent1"/>
+          </a:effectRef>
+          <a:fontRef idx="minor">
+            <a:schemeClr val="lt1"/>
+          </a:fontRef>
+        </p:style>
+        <p:txBody>
+          <a:bodyPr rtlCol="0" anchor="ctr"/>
+          <a:lstStyle/>
+          <a:p>
+            <a:pPr algn="ctr"/>
+          </a:p>
+        </p:txBody>
+      </p:sp>
+      <p:sp>
+        <p:nvSpPr>
+          <p:cNvPr id="4" name="TextBox 3"/>
           <p:cNvSpPr txBox="1"/>
           <p:nvPr/>
         </p:nvSpPr>
         <p:spPr>
           <a:xfrm>
-            <a:off x="457200" y="365760"/>
-            <a:ext cx="11247120" cy="822960"/>
+            <a:off x="640080" y="164592"/>
+            <a:ext cx="10515600" cy="731520"/>
           </a:xfrm>
           <a:prstGeom prst="rect">
             <a:avLst/>
@@ -3524,18 +5513,191 @@
           <a:noFill/>
         </p:spPr>
         <p:txBody>
-          <a:bodyPr wrap="none">
-            <a:spAutoFit/>
-          </a:bodyPr>
-          <a:lstStyle/>
-          <a:p>
-            <a:r>
-              <a:rPr sz="2400" b="1">
+          <a:bodyPr wrap="square"/>
+          <a:lstStyle/>
+          <a:p>
+            <a:pPr algn="l">
+              <a:spcBef>
+                <a:spcPts val="0"/>
+              </a:spcBef>
+              <a:spcAft>
+                <a:spcPts val="0"/>
+              </a:spcAft>
+            </a:pPr>
+            <a:r>
+              <a:rPr sz="2200" b="1">
                 <a:solidFill>
-                  <a:srgbClr val="0B3D91"/>
+                  <a:srgbClr val="111111"/>
                 </a:solidFill>
+                <a:latin typeface="Calibri"/>
               </a:rPr>
               <a:t>[6/12] Chart 4</a:t>
+            </a:r>
+          </a:p>
+        </p:txBody>
+      </p:sp>
+      <p:sp>
+        <p:nvSpPr>
+          <p:cNvPr id="5" name="Rectangle 4"/>
+          <p:cNvSpPr/>
+          <p:nvPr/>
+        </p:nvSpPr>
+        <p:spPr>
+          <a:xfrm>
+            <a:off x="640080" y="1042415"/>
+            <a:ext cx="10058400" cy="18288"/>
+          </a:xfrm>
+          <a:prstGeom prst="rect">
+            <a:avLst/>
+          </a:prstGeom>
+          <a:solidFill>
+            <a:srgbClr val="9CA3AF"/>
+          </a:solidFill>
+          <a:ln>
+            <a:noFill/>
+          </a:ln>
+        </p:spPr>
+        <p:style>
+          <a:lnRef idx="1">
+            <a:schemeClr val="accent1"/>
+          </a:lnRef>
+          <a:fillRef idx="3">
+            <a:schemeClr val="accent1"/>
+          </a:fillRef>
+          <a:effectRef idx="2">
+            <a:schemeClr val="accent1"/>
+          </a:effectRef>
+          <a:fontRef idx="minor">
+            <a:schemeClr val="lt1"/>
+          </a:fontRef>
+        </p:style>
+        <p:txBody>
+          <a:bodyPr rtlCol="0" anchor="ctr"/>
+          <a:lstStyle/>
+          <a:p>
+            <a:pPr algn="ctr"/>
+          </a:p>
+        </p:txBody>
+      </p:sp>
+      <p:sp>
+        <p:nvSpPr>
+          <p:cNvPr id="6" name="Rectangle 5"/>
+          <p:cNvSpPr/>
+          <p:nvPr/>
+        </p:nvSpPr>
+        <p:spPr>
+          <a:xfrm>
+            <a:off x="640080" y="6446520"/>
+            <a:ext cx="10515600" cy="9144"/>
+          </a:xfrm>
+          <a:prstGeom prst="rect">
+            <a:avLst/>
+          </a:prstGeom>
+          <a:solidFill>
+            <a:srgbClr val="9CA3AF"/>
+          </a:solidFill>
+          <a:ln>
+            <a:noFill/>
+          </a:ln>
+        </p:spPr>
+        <p:style>
+          <a:lnRef idx="1">
+            <a:schemeClr val="accent1"/>
+          </a:lnRef>
+          <a:fillRef idx="3">
+            <a:schemeClr val="accent1"/>
+          </a:fillRef>
+          <a:effectRef idx="2">
+            <a:schemeClr val="accent1"/>
+          </a:effectRef>
+          <a:fontRef idx="minor">
+            <a:schemeClr val="lt1"/>
+          </a:fontRef>
+        </p:style>
+        <p:txBody>
+          <a:bodyPr rtlCol="0" anchor="ctr"/>
+          <a:lstStyle/>
+          <a:p>
+            <a:pPr algn="ctr"/>
+          </a:p>
+        </p:txBody>
+      </p:sp>
+      <p:sp>
+        <p:nvSpPr>
+          <p:cNvPr id="7" name="TextBox 6"/>
+          <p:cNvSpPr txBox="1"/>
+          <p:nvPr/>
+        </p:nvSpPr>
+        <p:spPr>
+          <a:xfrm>
+            <a:off x="11155680" y="6492240"/>
+            <a:ext cx="731520" cy="274320"/>
+          </a:xfrm>
+          <a:prstGeom prst="rect">
+            <a:avLst/>
+          </a:prstGeom>
+          <a:noFill/>
+        </p:spPr>
+        <p:txBody>
+          <a:bodyPr wrap="square"/>
+          <a:lstStyle/>
+          <a:p>
+            <a:pPr algn="r">
+              <a:spcBef>
+                <a:spcPts val="0"/>
+              </a:spcBef>
+              <a:spcAft>
+                <a:spcPts val="0"/>
+              </a:spcAft>
+            </a:pPr>
+            <a:r>
+              <a:rPr sz="900" b="0">
+                <a:solidFill>
+                  <a:srgbClr val="9CA3AF"/>
+                </a:solidFill>
+                <a:latin typeface="Calibri"/>
+              </a:rPr>
+              <a:t>6/12</a:t>
+            </a:r>
+          </a:p>
+        </p:txBody>
+      </p:sp>
+      <p:sp>
+        <p:nvSpPr>
+          <p:cNvPr id="8" name="TextBox 7"/>
+          <p:cNvSpPr txBox="1"/>
+          <p:nvPr/>
+        </p:nvSpPr>
+        <p:spPr>
+          <a:xfrm>
+            <a:off x="640080" y="6492240"/>
+            <a:ext cx="2743200" cy="274320"/>
+          </a:xfrm>
+          <a:prstGeom prst="rect">
+            <a:avLst/>
+          </a:prstGeom>
+          <a:noFill/>
+        </p:spPr>
+        <p:txBody>
+          <a:bodyPr wrap="square"/>
+          <a:lstStyle/>
+          <a:p>
+            <a:pPr algn="l">
+              <a:spcBef>
+                <a:spcPts val="0"/>
+              </a:spcBef>
+              <a:spcAft>
+                <a:spcPts val="0"/>
+              </a:spcAft>
+            </a:pPr>
+            <a:r>
+              <a:rPr sz="800" b="0">
+                <a:solidFill>
+                  <a:srgbClr val="9CA3AF"/>
+                </a:solidFill>
+                <a:latin typeface="Calibri"/>
+              </a:rPr>
+              <a:t>CONFIDENTIEL</a:t>
             </a:r>
           </a:p>
         </p:txBody>
@@ -3560,14 +5722,100 @@
       <p:grpSpPr/>
       <p:sp>
         <p:nvSpPr>
-          <p:cNvPr id="2" name="TextBox 1"/>
+          <p:cNvPr id="2" name="Rectangle 1"/>
+          <p:cNvSpPr/>
+          <p:nvPr/>
+        </p:nvSpPr>
+        <p:spPr>
+          <a:xfrm>
+            <a:off x="0" y="0"/>
+            <a:ext cx="12191695" cy="36576"/>
+          </a:xfrm>
+          <a:prstGeom prst="rect">
+            <a:avLst/>
+          </a:prstGeom>
+          <a:solidFill>
+            <a:srgbClr val="E63946"/>
+          </a:solidFill>
+          <a:ln>
+            <a:noFill/>
+          </a:ln>
+        </p:spPr>
+        <p:style>
+          <a:lnRef idx="1">
+            <a:schemeClr val="accent1"/>
+          </a:lnRef>
+          <a:fillRef idx="3">
+            <a:schemeClr val="accent1"/>
+          </a:fillRef>
+          <a:effectRef idx="2">
+            <a:schemeClr val="accent1"/>
+          </a:effectRef>
+          <a:fontRef idx="minor">
+            <a:schemeClr val="lt1"/>
+          </a:fontRef>
+        </p:style>
+        <p:txBody>
+          <a:bodyPr rtlCol="0" anchor="ctr"/>
+          <a:lstStyle/>
+          <a:p>
+            <a:pPr algn="ctr"/>
+          </a:p>
+        </p:txBody>
+      </p:sp>
+      <p:sp>
+        <p:nvSpPr>
+          <p:cNvPr id="3" name="Rectangle 2"/>
+          <p:cNvSpPr/>
+          <p:nvPr/>
+        </p:nvSpPr>
+        <p:spPr>
+          <a:xfrm>
+            <a:off x="0" y="36576"/>
+            <a:ext cx="12191695" cy="1005840"/>
+          </a:xfrm>
+          <a:prstGeom prst="rect">
+            <a:avLst/>
+          </a:prstGeom>
+          <a:solidFill>
+            <a:srgbClr val="F5F5F5"/>
+          </a:solidFill>
+          <a:ln>
+            <a:noFill/>
+          </a:ln>
+        </p:spPr>
+        <p:style>
+          <a:lnRef idx="1">
+            <a:schemeClr val="accent1"/>
+          </a:lnRef>
+          <a:fillRef idx="3">
+            <a:schemeClr val="accent1"/>
+          </a:fillRef>
+          <a:effectRef idx="2">
+            <a:schemeClr val="accent1"/>
+          </a:effectRef>
+          <a:fontRef idx="minor">
+            <a:schemeClr val="lt1"/>
+          </a:fontRef>
+        </p:style>
+        <p:txBody>
+          <a:bodyPr rtlCol="0" anchor="ctr"/>
+          <a:lstStyle/>
+          <a:p>
+            <a:pPr algn="ctr"/>
+          </a:p>
+        </p:txBody>
+      </p:sp>
+      <p:sp>
+        <p:nvSpPr>
+          <p:cNvPr id="4" name="TextBox 3"/>
           <p:cNvSpPr txBox="1"/>
           <p:nvPr/>
         </p:nvSpPr>
         <p:spPr>
           <a:xfrm>
-            <a:off x="457200" y="365760"/>
-            <a:ext cx="11247120" cy="822960"/>
+            <a:off x="640080" y="164592"/>
+            <a:ext cx="10515600" cy="731520"/>
           </a:xfrm>
           <a:prstGeom prst="rect">
             <a:avLst/>
@@ -3575,18 +5823,191 @@
           <a:noFill/>
         </p:spPr>
         <p:txBody>
-          <a:bodyPr wrap="none">
-            <a:spAutoFit/>
-          </a:bodyPr>
-          <a:lstStyle/>
-          <a:p>
-            <a:r>
-              <a:rPr sz="2400" b="1">
+          <a:bodyPr wrap="square"/>
+          <a:lstStyle/>
+          <a:p>
+            <a:pPr algn="l">
+              <a:spcBef>
+                <a:spcPts val="0"/>
+              </a:spcBef>
+              <a:spcAft>
+                <a:spcPts val="0"/>
+              </a:spcAft>
+            </a:pPr>
+            <a:r>
+              <a:rPr sz="2200" b="1">
                 <a:solidFill>
-                  <a:srgbClr val="0B3D91"/>
+                  <a:srgbClr val="111111"/>
                 </a:solidFill>
+                <a:latin typeface="Calibri"/>
               </a:rPr>
               <a:t>[7/12] Chart 5</a:t>
+            </a:r>
+          </a:p>
+        </p:txBody>
+      </p:sp>
+      <p:sp>
+        <p:nvSpPr>
+          <p:cNvPr id="5" name="Rectangle 4"/>
+          <p:cNvSpPr/>
+          <p:nvPr/>
+        </p:nvSpPr>
+        <p:spPr>
+          <a:xfrm>
+            <a:off x="640080" y="1042415"/>
+            <a:ext cx="10058400" cy="18288"/>
+          </a:xfrm>
+          <a:prstGeom prst="rect">
+            <a:avLst/>
+          </a:prstGeom>
+          <a:solidFill>
+            <a:srgbClr val="9CA3AF"/>
+          </a:solidFill>
+          <a:ln>
+            <a:noFill/>
+          </a:ln>
+        </p:spPr>
+        <p:style>
+          <a:lnRef idx="1">
+            <a:schemeClr val="accent1"/>
+          </a:lnRef>
+          <a:fillRef idx="3">
+            <a:schemeClr val="accent1"/>
+          </a:fillRef>
+          <a:effectRef idx="2">
+            <a:schemeClr val="accent1"/>
+          </a:effectRef>
+          <a:fontRef idx="minor">
+            <a:schemeClr val="lt1"/>
+          </a:fontRef>
+        </p:style>
+        <p:txBody>
+          <a:bodyPr rtlCol="0" anchor="ctr"/>
+          <a:lstStyle/>
+          <a:p>
+            <a:pPr algn="ctr"/>
+          </a:p>
+        </p:txBody>
+      </p:sp>
+      <p:sp>
+        <p:nvSpPr>
+          <p:cNvPr id="6" name="Rectangle 5"/>
+          <p:cNvSpPr/>
+          <p:nvPr/>
+        </p:nvSpPr>
+        <p:spPr>
+          <a:xfrm>
+            <a:off x="640080" y="6446520"/>
+            <a:ext cx="10515600" cy="9144"/>
+          </a:xfrm>
+          <a:prstGeom prst="rect">
+            <a:avLst/>
+          </a:prstGeom>
+          <a:solidFill>
+            <a:srgbClr val="9CA3AF"/>
+          </a:solidFill>
+          <a:ln>
+            <a:noFill/>
+          </a:ln>
+        </p:spPr>
+        <p:style>
+          <a:lnRef idx="1">
+            <a:schemeClr val="accent1"/>
+          </a:lnRef>
+          <a:fillRef idx="3">
+            <a:schemeClr val="accent1"/>
+          </a:fillRef>
+          <a:effectRef idx="2">
+            <a:schemeClr val="accent1"/>
+          </a:effectRef>
+          <a:fontRef idx="minor">
+            <a:schemeClr val="lt1"/>
+          </a:fontRef>
+        </p:style>
+        <p:txBody>
+          <a:bodyPr rtlCol="0" anchor="ctr"/>
+          <a:lstStyle/>
+          <a:p>
+            <a:pPr algn="ctr"/>
+          </a:p>
+        </p:txBody>
+      </p:sp>
+      <p:sp>
+        <p:nvSpPr>
+          <p:cNvPr id="7" name="TextBox 6"/>
+          <p:cNvSpPr txBox="1"/>
+          <p:nvPr/>
+        </p:nvSpPr>
+        <p:spPr>
+          <a:xfrm>
+            <a:off x="11155680" y="6492240"/>
+            <a:ext cx="731520" cy="274320"/>
+          </a:xfrm>
+          <a:prstGeom prst="rect">
+            <a:avLst/>
+          </a:prstGeom>
+          <a:noFill/>
+        </p:spPr>
+        <p:txBody>
+          <a:bodyPr wrap="square"/>
+          <a:lstStyle/>
+          <a:p>
+            <a:pPr algn="r">
+              <a:spcBef>
+                <a:spcPts val="0"/>
+              </a:spcBef>
+              <a:spcAft>
+                <a:spcPts val="0"/>
+              </a:spcAft>
+            </a:pPr>
+            <a:r>
+              <a:rPr sz="900" b="0">
+                <a:solidFill>
+                  <a:srgbClr val="9CA3AF"/>
+                </a:solidFill>
+                <a:latin typeface="Calibri"/>
+              </a:rPr>
+              <a:t>7/12</a:t>
+            </a:r>
+          </a:p>
+        </p:txBody>
+      </p:sp>
+      <p:sp>
+        <p:nvSpPr>
+          <p:cNvPr id="8" name="TextBox 7"/>
+          <p:cNvSpPr txBox="1"/>
+          <p:nvPr/>
+        </p:nvSpPr>
+        <p:spPr>
+          <a:xfrm>
+            <a:off x="640080" y="6492240"/>
+            <a:ext cx="2743200" cy="274320"/>
+          </a:xfrm>
+          <a:prstGeom prst="rect">
+            <a:avLst/>
+          </a:prstGeom>
+          <a:noFill/>
+        </p:spPr>
+        <p:txBody>
+          <a:bodyPr wrap="square"/>
+          <a:lstStyle/>
+          <a:p>
+            <a:pPr algn="l">
+              <a:spcBef>
+                <a:spcPts val="0"/>
+              </a:spcBef>
+              <a:spcAft>
+                <a:spcPts val="0"/>
+              </a:spcAft>
+            </a:pPr>
+            <a:r>
+              <a:rPr sz="800" b="0">
+                <a:solidFill>
+                  <a:srgbClr val="9CA3AF"/>
+                </a:solidFill>
+                <a:latin typeface="Calibri"/>
+              </a:rPr>
+              <a:t>CONFIDENTIEL</a:t>
             </a:r>
           </a:p>
         </p:txBody>
@@ -3611,14 +6032,100 @@
       <p:grpSpPr/>
       <p:sp>
         <p:nvSpPr>
-          <p:cNvPr id="2" name="TextBox 1"/>
+          <p:cNvPr id="2" name="Rectangle 1"/>
+          <p:cNvSpPr/>
+          <p:nvPr/>
+        </p:nvSpPr>
+        <p:spPr>
+          <a:xfrm>
+            <a:off x="0" y="0"/>
+            <a:ext cx="12191695" cy="36576"/>
+          </a:xfrm>
+          <a:prstGeom prst="rect">
+            <a:avLst/>
+          </a:prstGeom>
+          <a:solidFill>
+            <a:srgbClr val="E63946"/>
+          </a:solidFill>
+          <a:ln>
+            <a:noFill/>
+          </a:ln>
+        </p:spPr>
+        <p:style>
+          <a:lnRef idx="1">
+            <a:schemeClr val="accent1"/>
+          </a:lnRef>
+          <a:fillRef idx="3">
+            <a:schemeClr val="accent1"/>
+          </a:fillRef>
+          <a:effectRef idx="2">
+            <a:schemeClr val="accent1"/>
+          </a:effectRef>
+          <a:fontRef idx="minor">
+            <a:schemeClr val="lt1"/>
+          </a:fontRef>
+        </p:style>
+        <p:txBody>
+          <a:bodyPr rtlCol="0" anchor="ctr"/>
+          <a:lstStyle/>
+          <a:p>
+            <a:pPr algn="ctr"/>
+          </a:p>
+        </p:txBody>
+      </p:sp>
+      <p:sp>
+        <p:nvSpPr>
+          <p:cNvPr id="3" name="Rectangle 2"/>
+          <p:cNvSpPr/>
+          <p:nvPr/>
+        </p:nvSpPr>
+        <p:spPr>
+          <a:xfrm>
+            <a:off x="0" y="36576"/>
+            <a:ext cx="12191695" cy="1005840"/>
+          </a:xfrm>
+          <a:prstGeom prst="rect">
+            <a:avLst/>
+          </a:prstGeom>
+          <a:solidFill>
+            <a:srgbClr val="F5F5F5"/>
+          </a:solidFill>
+          <a:ln>
+            <a:noFill/>
+          </a:ln>
+        </p:spPr>
+        <p:style>
+          <a:lnRef idx="1">
+            <a:schemeClr val="accent1"/>
+          </a:lnRef>
+          <a:fillRef idx="3">
+            <a:schemeClr val="accent1"/>
+          </a:fillRef>
+          <a:effectRef idx="2">
+            <a:schemeClr val="accent1"/>
+          </a:effectRef>
+          <a:fontRef idx="minor">
+            <a:schemeClr val="lt1"/>
+          </a:fontRef>
+        </p:style>
+        <p:txBody>
+          <a:bodyPr rtlCol="0" anchor="ctr"/>
+          <a:lstStyle/>
+          <a:p>
+            <a:pPr algn="ctr"/>
+          </a:p>
+        </p:txBody>
+      </p:sp>
+      <p:sp>
+        <p:nvSpPr>
+          <p:cNvPr id="4" name="TextBox 3"/>
           <p:cNvSpPr txBox="1"/>
           <p:nvPr/>
         </p:nvSpPr>
         <p:spPr>
           <a:xfrm>
-            <a:off x="457200" y="365760"/>
-            <a:ext cx="11247120" cy="822960"/>
+            <a:off x="640080" y="164592"/>
+            <a:ext cx="10515600" cy="731520"/>
           </a:xfrm>
           <a:prstGeom prst="rect">
             <a:avLst/>
@@ -3626,18 +6133,191 @@
           <a:noFill/>
         </p:spPr>
         <p:txBody>
-          <a:bodyPr wrap="none">
-            <a:spAutoFit/>
-          </a:bodyPr>
-          <a:lstStyle/>
-          <a:p>
-            <a:r>
-              <a:rPr sz="2400" b="1">
+          <a:bodyPr wrap="square"/>
+          <a:lstStyle/>
+          <a:p>
+            <a:pPr algn="l">
+              <a:spcBef>
+                <a:spcPts val="0"/>
+              </a:spcBef>
+              <a:spcAft>
+                <a:spcPts val="0"/>
+              </a:spcAft>
+            </a:pPr>
+            <a:r>
+              <a:rPr sz="2200" b="1">
                 <a:solidFill>
-                  <a:srgbClr val="0B3D91"/>
+                  <a:srgbClr val="111111"/>
                 </a:solidFill>
+                <a:latin typeface="Calibri"/>
               </a:rPr>
               <a:t>[8/12] Chart 6</a:t>
+            </a:r>
+          </a:p>
+        </p:txBody>
+      </p:sp>
+      <p:sp>
+        <p:nvSpPr>
+          <p:cNvPr id="5" name="Rectangle 4"/>
+          <p:cNvSpPr/>
+          <p:nvPr/>
+        </p:nvSpPr>
+        <p:spPr>
+          <a:xfrm>
+            <a:off x="640080" y="1042415"/>
+            <a:ext cx="10058400" cy="18288"/>
+          </a:xfrm>
+          <a:prstGeom prst="rect">
+            <a:avLst/>
+          </a:prstGeom>
+          <a:solidFill>
+            <a:srgbClr val="9CA3AF"/>
+          </a:solidFill>
+          <a:ln>
+            <a:noFill/>
+          </a:ln>
+        </p:spPr>
+        <p:style>
+          <a:lnRef idx="1">
+            <a:schemeClr val="accent1"/>
+          </a:lnRef>
+          <a:fillRef idx="3">
+            <a:schemeClr val="accent1"/>
+          </a:fillRef>
+          <a:effectRef idx="2">
+            <a:schemeClr val="accent1"/>
+          </a:effectRef>
+          <a:fontRef idx="minor">
+            <a:schemeClr val="lt1"/>
+          </a:fontRef>
+        </p:style>
+        <p:txBody>
+          <a:bodyPr rtlCol="0" anchor="ctr"/>
+          <a:lstStyle/>
+          <a:p>
+            <a:pPr algn="ctr"/>
+          </a:p>
+        </p:txBody>
+      </p:sp>
+      <p:sp>
+        <p:nvSpPr>
+          <p:cNvPr id="6" name="Rectangle 5"/>
+          <p:cNvSpPr/>
+          <p:nvPr/>
+        </p:nvSpPr>
+        <p:spPr>
+          <a:xfrm>
+            <a:off x="640080" y="6446520"/>
+            <a:ext cx="10515600" cy="9144"/>
+          </a:xfrm>
+          <a:prstGeom prst="rect">
+            <a:avLst/>
+          </a:prstGeom>
+          <a:solidFill>
+            <a:srgbClr val="9CA3AF"/>
+          </a:solidFill>
+          <a:ln>
+            <a:noFill/>
+          </a:ln>
+        </p:spPr>
+        <p:style>
+          <a:lnRef idx="1">
+            <a:schemeClr val="accent1"/>
+          </a:lnRef>
+          <a:fillRef idx="3">
+            <a:schemeClr val="accent1"/>
+          </a:fillRef>
+          <a:effectRef idx="2">
+            <a:schemeClr val="accent1"/>
+          </a:effectRef>
+          <a:fontRef idx="minor">
+            <a:schemeClr val="lt1"/>
+          </a:fontRef>
+        </p:style>
+        <p:txBody>
+          <a:bodyPr rtlCol="0" anchor="ctr"/>
+          <a:lstStyle/>
+          <a:p>
+            <a:pPr algn="ctr"/>
+          </a:p>
+        </p:txBody>
+      </p:sp>
+      <p:sp>
+        <p:nvSpPr>
+          <p:cNvPr id="7" name="TextBox 6"/>
+          <p:cNvSpPr txBox="1"/>
+          <p:nvPr/>
+        </p:nvSpPr>
+        <p:spPr>
+          <a:xfrm>
+            <a:off x="11155680" y="6492240"/>
+            <a:ext cx="731520" cy="274320"/>
+          </a:xfrm>
+          <a:prstGeom prst="rect">
+            <a:avLst/>
+          </a:prstGeom>
+          <a:noFill/>
+        </p:spPr>
+        <p:txBody>
+          <a:bodyPr wrap="square"/>
+          <a:lstStyle/>
+          <a:p>
+            <a:pPr algn="r">
+              <a:spcBef>
+                <a:spcPts val="0"/>
+              </a:spcBef>
+              <a:spcAft>
+                <a:spcPts val="0"/>
+              </a:spcAft>
+            </a:pPr>
+            <a:r>
+              <a:rPr sz="900" b="0">
+                <a:solidFill>
+                  <a:srgbClr val="9CA3AF"/>
+                </a:solidFill>
+                <a:latin typeface="Calibri"/>
+              </a:rPr>
+              <a:t>8/12</a:t>
+            </a:r>
+          </a:p>
+        </p:txBody>
+      </p:sp>
+      <p:sp>
+        <p:nvSpPr>
+          <p:cNvPr id="8" name="TextBox 7"/>
+          <p:cNvSpPr txBox="1"/>
+          <p:nvPr/>
+        </p:nvSpPr>
+        <p:spPr>
+          <a:xfrm>
+            <a:off x="640080" y="6492240"/>
+            <a:ext cx="2743200" cy="274320"/>
+          </a:xfrm>
+          <a:prstGeom prst="rect">
+            <a:avLst/>
+          </a:prstGeom>
+          <a:noFill/>
+        </p:spPr>
+        <p:txBody>
+          <a:bodyPr wrap="square"/>
+          <a:lstStyle/>
+          <a:p>
+            <a:pPr algn="l">
+              <a:spcBef>
+                <a:spcPts val="0"/>
+              </a:spcBef>
+              <a:spcAft>
+                <a:spcPts val="0"/>
+              </a:spcAft>
+            </a:pPr>
+            <a:r>
+              <a:rPr sz="800" b="0">
+                <a:solidFill>
+                  <a:srgbClr val="9CA3AF"/>
+                </a:solidFill>
+                <a:latin typeface="Calibri"/>
+              </a:rPr>
+              <a:t>CONFIDENTIEL</a:t>
             </a:r>
           </a:p>
         </p:txBody>
@@ -3662,14 +6342,100 @@
       <p:grpSpPr/>
       <p:sp>
         <p:nvSpPr>
-          <p:cNvPr id="2" name="TextBox 1"/>
+          <p:cNvPr id="2" name="Rectangle 1"/>
+          <p:cNvSpPr/>
+          <p:nvPr/>
+        </p:nvSpPr>
+        <p:spPr>
+          <a:xfrm>
+            <a:off x="0" y="0"/>
+            <a:ext cx="12191695" cy="36576"/>
+          </a:xfrm>
+          <a:prstGeom prst="rect">
+            <a:avLst/>
+          </a:prstGeom>
+          <a:solidFill>
+            <a:srgbClr val="E63946"/>
+          </a:solidFill>
+          <a:ln>
+            <a:noFill/>
+          </a:ln>
+        </p:spPr>
+        <p:style>
+          <a:lnRef idx="1">
+            <a:schemeClr val="accent1"/>
+          </a:lnRef>
+          <a:fillRef idx="3">
+            <a:schemeClr val="accent1"/>
+          </a:fillRef>
+          <a:effectRef idx="2">
+            <a:schemeClr val="accent1"/>
+          </a:effectRef>
+          <a:fontRef idx="minor">
+            <a:schemeClr val="lt1"/>
+          </a:fontRef>
+        </p:style>
+        <p:txBody>
+          <a:bodyPr rtlCol="0" anchor="ctr"/>
+          <a:lstStyle/>
+          <a:p>
+            <a:pPr algn="ctr"/>
+          </a:p>
+        </p:txBody>
+      </p:sp>
+      <p:sp>
+        <p:nvSpPr>
+          <p:cNvPr id="3" name="Rectangle 2"/>
+          <p:cNvSpPr/>
+          <p:nvPr/>
+        </p:nvSpPr>
+        <p:spPr>
+          <a:xfrm>
+            <a:off x="0" y="36576"/>
+            <a:ext cx="12191695" cy="1005840"/>
+          </a:xfrm>
+          <a:prstGeom prst="rect">
+            <a:avLst/>
+          </a:prstGeom>
+          <a:solidFill>
+            <a:srgbClr val="F5F5F5"/>
+          </a:solidFill>
+          <a:ln>
+            <a:noFill/>
+          </a:ln>
+        </p:spPr>
+        <p:style>
+          <a:lnRef idx="1">
+            <a:schemeClr val="accent1"/>
+          </a:lnRef>
+          <a:fillRef idx="3">
+            <a:schemeClr val="accent1"/>
+          </a:fillRef>
+          <a:effectRef idx="2">
+            <a:schemeClr val="accent1"/>
+          </a:effectRef>
+          <a:fontRef idx="minor">
+            <a:schemeClr val="lt1"/>
+          </a:fontRef>
+        </p:style>
+        <p:txBody>
+          <a:bodyPr rtlCol="0" anchor="ctr"/>
+          <a:lstStyle/>
+          <a:p>
+            <a:pPr algn="ctr"/>
+          </a:p>
+        </p:txBody>
+      </p:sp>
+      <p:sp>
+        <p:nvSpPr>
+          <p:cNvPr id="4" name="TextBox 3"/>
           <p:cNvSpPr txBox="1"/>
           <p:nvPr/>
         </p:nvSpPr>
         <p:spPr>
           <a:xfrm>
-            <a:off x="457200" y="365760"/>
-            <a:ext cx="11247120" cy="822960"/>
+            <a:off x="640080" y="164592"/>
+            <a:ext cx="10515600" cy="731520"/>
           </a:xfrm>
           <a:prstGeom prst="rect">
             <a:avLst/>
@@ -3677,18 +6443,191 @@
           <a:noFill/>
         </p:spPr>
         <p:txBody>
-          <a:bodyPr wrap="none">
-            <a:spAutoFit/>
-          </a:bodyPr>
-          <a:lstStyle/>
-          <a:p>
-            <a:r>
-              <a:rPr sz="2400" b="1">
+          <a:bodyPr wrap="square"/>
+          <a:lstStyle/>
+          <a:p>
+            <a:pPr algn="l">
+              <a:spcBef>
+                <a:spcPts val="0"/>
+              </a:spcBef>
+              <a:spcAft>
+                <a:spcPts val="0"/>
+              </a:spcAft>
+            </a:pPr>
+            <a:r>
+              <a:rPr sz="2200" b="1">
                 <a:solidFill>
-                  <a:srgbClr val="0B3D91"/>
+                  <a:srgbClr val="111111"/>
                 </a:solidFill>
+                <a:latin typeface="Calibri"/>
               </a:rPr>
               <a:t>[9/12] Chart 7</a:t>
+            </a:r>
+          </a:p>
+        </p:txBody>
+      </p:sp>
+      <p:sp>
+        <p:nvSpPr>
+          <p:cNvPr id="5" name="Rectangle 4"/>
+          <p:cNvSpPr/>
+          <p:nvPr/>
+        </p:nvSpPr>
+        <p:spPr>
+          <a:xfrm>
+            <a:off x="640080" y="1042415"/>
+            <a:ext cx="10058400" cy="18288"/>
+          </a:xfrm>
+          <a:prstGeom prst="rect">
+            <a:avLst/>
+          </a:prstGeom>
+          <a:solidFill>
+            <a:srgbClr val="9CA3AF"/>
+          </a:solidFill>
+          <a:ln>
+            <a:noFill/>
+          </a:ln>
+        </p:spPr>
+        <p:style>
+          <a:lnRef idx="1">
+            <a:schemeClr val="accent1"/>
+          </a:lnRef>
+          <a:fillRef idx="3">
+            <a:schemeClr val="accent1"/>
+          </a:fillRef>
+          <a:effectRef idx="2">
+            <a:schemeClr val="accent1"/>
+          </a:effectRef>
+          <a:fontRef idx="minor">
+            <a:schemeClr val="lt1"/>
+          </a:fontRef>
+        </p:style>
+        <p:txBody>
+          <a:bodyPr rtlCol="0" anchor="ctr"/>
+          <a:lstStyle/>
+          <a:p>
+            <a:pPr algn="ctr"/>
+          </a:p>
+        </p:txBody>
+      </p:sp>
+      <p:sp>
+        <p:nvSpPr>
+          <p:cNvPr id="6" name="Rectangle 5"/>
+          <p:cNvSpPr/>
+          <p:nvPr/>
+        </p:nvSpPr>
+        <p:spPr>
+          <a:xfrm>
+            <a:off x="640080" y="6446520"/>
+            <a:ext cx="10515600" cy="9144"/>
+          </a:xfrm>
+          <a:prstGeom prst="rect">
+            <a:avLst/>
+          </a:prstGeom>
+          <a:solidFill>
+            <a:srgbClr val="9CA3AF"/>
+          </a:solidFill>
+          <a:ln>
+            <a:noFill/>
+          </a:ln>
+        </p:spPr>
+        <p:style>
+          <a:lnRef idx="1">
+            <a:schemeClr val="accent1"/>
+          </a:lnRef>
+          <a:fillRef idx="3">
+            <a:schemeClr val="accent1"/>
+          </a:fillRef>
+          <a:effectRef idx="2">
+            <a:schemeClr val="accent1"/>
+          </a:effectRef>
+          <a:fontRef idx="minor">
+            <a:schemeClr val="lt1"/>
+          </a:fontRef>
+        </p:style>
+        <p:txBody>
+          <a:bodyPr rtlCol="0" anchor="ctr"/>
+          <a:lstStyle/>
+          <a:p>
+            <a:pPr algn="ctr"/>
+          </a:p>
+        </p:txBody>
+      </p:sp>
+      <p:sp>
+        <p:nvSpPr>
+          <p:cNvPr id="7" name="TextBox 6"/>
+          <p:cNvSpPr txBox="1"/>
+          <p:nvPr/>
+        </p:nvSpPr>
+        <p:spPr>
+          <a:xfrm>
+            <a:off x="11155680" y="6492240"/>
+            <a:ext cx="731520" cy="274320"/>
+          </a:xfrm>
+          <a:prstGeom prst="rect">
+            <a:avLst/>
+          </a:prstGeom>
+          <a:noFill/>
+        </p:spPr>
+        <p:txBody>
+          <a:bodyPr wrap="square"/>
+          <a:lstStyle/>
+          <a:p>
+            <a:pPr algn="r">
+              <a:spcBef>
+                <a:spcPts val="0"/>
+              </a:spcBef>
+              <a:spcAft>
+                <a:spcPts val="0"/>
+              </a:spcAft>
+            </a:pPr>
+            <a:r>
+              <a:rPr sz="900" b="0">
+                <a:solidFill>
+                  <a:srgbClr val="9CA3AF"/>
+                </a:solidFill>
+                <a:latin typeface="Calibri"/>
+              </a:rPr>
+              <a:t>9/12</a:t>
+            </a:r>
+          </a:p>
+        </p:txBody>
+      </p:sp>
+      <p:sp>
+        <p:nvSpPr>
+          <p:cNvPr id="8" name="TextBox 7"/>
+          <p:cNvSpPr txBox="1"/>
+          <p:nvPr/>
+        </p:nvSpPr>
+        <p:spPr>
+          <a:xfrm>
+            <a:off x="640080" y="6492240"/>
+            <a:ext cx="2743200" cy="274320"/>
+          </a:xfrm>
+          <a:prstGeom prst="rect">
+            <a:avLst/>
+          </a:prstGeom>
+          <a:noFill/>
+        </p:spPr>
+        <p:txBody>
+          <a:bodyPr wrap="square"/>
+          <a:lstStyle/>
+          <a:p>
+            <a:pPr algn="l">
+              <a:spcBef>
+                <a:spcPts val="0"/>
+              </a:spcBef>
+              <a:spcAft>
+                <a:spcPts val="0"/>
+              </a:spcAft>
+            </a:pPr>
+            <a:r>
+              <a:rPr sz="800" b="0">
+                <a:solidFill>
+                  <a:srgbClr val="9CA3AF"/>
+                </a:solidFill>
+                <a:latin typeface="Calibri"/>
+              </a:rPr>
+              <a:t>CONFIDENTIEL</a:t>
             </a:r>
           </a:p>
         </p:txBody>

</xml_diff>